<commit_message>
Livret PPTX : corriger chevauchement texte/image slide 7 (Jouons ensemble)
Co-Authored-By: Claude Opus 4.6 <noreply@anthropic.com>
</commit_message>
<xml_diff>
--- a/documents/Livret-SED-enfant-SedOcc.pptx
+++ b/documents/Livret-SED-enfant-SedOcc.pptx
@@ -5469,7 +5469,7 @@
         <p:spPr>
           <a:xfrm>
             <a:off x="592319" y="3006060"/>
-            <a:ext cx="5040000" cy="1345000"/>
+            <a:ext cx="5040000" cy="1620000"/>
           </a:xfrm>
           <a:prstGeom prst="rect">
             <a:avLst/>
@@ -5536,8 +5536,8 @@
         </p:blipFill>
         <p:spPr>
           <a:xfrm>
-            <a:off x="823993" y="4759600"/>
-            <a:ext cx="5760000" cy="4140000"/>
+            <a:off x="1152000" y="4968000"/>
+            <a:ext cx="5256000" cy="3780000"/>
           </a:xfrm>
           <a:prstGeom prst="roundRect">
             <a:avLst>

</xml_diff>

<commit_message>
Livret PPTX slide 7 : reduire police texte 24 vers 20pt, plus d espace autour image
Co-Authored-By: Claude Opus 4.6 <noreply@anthropic.com>
</commit_message>
<xml_diff>
--- a/documents/Livret-SED-enfant-SedOcc.pptx
+++ b/documents/Livret-SED-enfant-SedOcc.pptx
@@ -5468,8 +5468,8 @@
         </p:nvSpPr>
         <p:spPr>
           <a:xfrm>
-            <a:off x="592319" y="3006060"/>
-            <a:ext cx="5040000" cy="1620000"/>
+            <a:off x="592319" y="3060000"/>
+            <a:ext cx="5220000" cy="1260000"/>
           </a:xfrm>
           <a:prstGeom prst="rect">
             <a:avLst/>
@@ -5485,7 +5485,7 @@
               <a:buNone/>
             </a:pPr>
             <a:r>
-              <a:rPr lang="fr-FR" sz="2400" dirty="0">
+              <a:rPr lang="fr-FR" sz="2000" dirty="0">
                 <a:solidFill>
                   <a:srgbClr val="333333"/>
                 </a:solidFill>
@@ -5496,7 +5496,7 @@
               <a:t>Dans la cour, on peut s'amuser ensemble à des </a:t>
             </a:r>
             <a:r>
-              <a:rPr lang="fr-FR" sz="2400" b="1" dirty="0">
+              <a:rPr lang="fr-FR" sz="2000" b="1" dirty="0">
                 <a:solidFill>
                   <a:srgbClr val="333333"/>
                 </a:solidFill>
@@ -5507,7 +5507,7 @@
               <a:t>jeux sans bousculade</a:t>
             </a:r>
             <a:r>
-              <a:rPr lang="fr-FR" sz="2400" dirty="0">
+              <a:rPr lang="fr-FR" sz="2000" dirty="0">
                 <a:solidFill>
                   <a:srgbClr val="333333"/>
                 </a:solidFill>
@@ -5536,8 +5536,8 @@
         </p:blipFill>
         <p:spPr>
           <a:xfrm>
-            <a:off x="1152000" y="4968000"/>
-            <a:ext cx="5256000" cy="3780000"/>
+            <a:off x="1026000" y="4500000"/>
+            <a:ext cx="5508000" cy="3960000"/>
           </a:xfrm>
           <a:prstGeom prst="roundRect">
             <a:avLst>
@@ -5861,7 +5861,7 @@
         </p:nvSpPr>
         <p:spPr>
           <a:xfrm>
-            <a:off x="786951" y="9050779"/>
+            <a:off x="786951" y="8640000"/>
             <a:ext cx="5867400" cy="461665"/>
           </a:xfrm>
           <a:prstGeom prst="rect">

</xml_diff>

<commit_message>
Livret PPTX : corrections manuelles slide Jouons ensemble
Co-Authored-By: Claude Opus 4.6 <noreply@anthropic.com>
</commit_message>
<xml_diff>
--- a/documents/Livret-SED-enfant-SedOcc.pptx
+++ b/documents/Livret-SED-enfant-SedOcc.pptx
@@ -5536,8 +5536,8 @@
         </p:blipFill>
         <p:spPr>
           <a:xfrm>
-            <a:off x="1026000" y="4500000"/>
-            <a:ext cx="5508000" cy="3960000"/>
+            <a:off x="1183280" y="4600682"/>
+            <a:ext cx="5041425" cy="3624554"/>
           </a:xfrm>
           <a:prstGeom prst="roundRect">
             <a:avLst>
@@ -6008,8 +6008,8 @@
         </p:nvSpPr>
         <p:spPr>
           <a:xfrm>
-            <a:off x="914781" y="5771474"/>
-            <a:ext cx="5533644" cy="2620845"/>
+            <a:off x="861939" y="5637894"/>
+            <a:ext cx="4773219" cy="2620845"/>
           </a:xfrm>
           <a:prstGeom prst="rect">
             <a:avLst/>
@@ -6068,19 +6068,6 @@
               </a:rPr>
               <a:t>C'est important de se sentir entouré.</a:t>
             </a:r>
-          </a:p>
-          <a:p>
-            <a:pPr algn="l">
-              <a:spcBef>
-                <a:spcPts val="400"/>
-              </a:spcBef>
-            </a:pPr>
-            <a:endParaRPr lang="fr-FR" sz="2400" b="1" dirty="0">
-              <a:solidFill>
-                <a:srgbClr val="333333"/>
-              </a:solidFill>
-              <a:latin typeface="Poppins"/>
-            </a:endParaRPr>
           </a:p>
           <a:p>
             <a:pPr algn="l">

</xml_diff>

<commit_message>
Livret : remplacer toutes les illustrations par des dessins style enfant cohérents
- 12 images remplacées (site web + PPTX) par des illustrations kawaii générées
- Suppression image mannequins inutile
- Alternance garçon/fille sur les illustrations

Co-Authored-By: Claude Opus 4.6 <noreply@anthropic.com>
</commit_message>
<xml_diff>
--- a/documents/Livret-SED-enfant-SedOcc.pptx
+++ b/documents/Livret-SED-enfant-SedOcc.pptx
@@ -212,7 +212,7 @@
           <a:p>
             <a:fld id="{A2B3F72A-3E22-47E7-995C-6D9D04600525}" type="datetimeFigureOut">
               <a:rPr lang="fr-FR" smtClean="0"/>
-              <a:t>29/06/2026</a:t>
+              <a:t>30/06/2026</a:t>
             </a:fld>
             <a:endParaRPr lang="fr-FR"/>
           </a:p>
@@ -1372,7 +1372,7 @@
           <a:p>
             <a:fld id="{1D8BD707-D9CF-40AE-B4C6-C98DA3205C09}" type="datetimeFigureOut">
               <a:rPr lang="en-US"/>
-              <a:t>6/29/26</a:t>
+              <a:t>6/30/26</a:t>
             </a:fld>
             <a:endParaRPr lang="en-US"/>
           </a:p>
@@ -1580,7 +1580,7 @@
           <a:p>
             <a:fld id="{1D8BD707-D9CF-40AE-B4C6-C98DA3205C09}" type="datetimeFigureOut">
               <a:rPr lang="en-US"/>
-              <a:t>6/29/26</a:t>
+              <a:t>6/30/26</a:t>
             </a:fld>
             <a:endParaRPr lang="en-US"/>
           </a:p>
@@ -1795,7 +1795,7 @@
           <a:p>
             <a:fld id="{1D8BD707-D9CF-40AE-B4C6-C98DA3205C09}" type="datetimeFigureOut">
               <a:rPr lang="en-US"/>
-              <a:t>6/29/26</a:t>
+              <a:t>6/30/26</a:t>
             </a:fld>
             <a:endParaRPr lang="en-US"/>
           </a:p>
@@ -1944,7 +1944,7 @@
           <a:p>
             <a:fld id="{1D8BD707-D9CF-40AE-B4C6-C98DA3205C09}" type="datetimeFigureOut">
               <a:rPr lang="en-US"/>
-              <a:t>6/29/26</a:t>
+              <a:t>6/30/26</a:t>
             </a:fld>
             <a:endParaRPr lang="en-US"/>
           </a:p>
@@ -2064,7 +2064,7 @@
           <a:p>
             <a:fld id="{1D8BD707-D9CF-40AE-B4C6-C98DA3205C09}" type="datetimeFigureOut">
               <a:rPr lang="en-US"/>
-              <a:t>6/29/26</a:t>
+              <a:t>6/30/26</a:t>
             </a:fld>
             <a:endParaRPr lang="en-US"/>
           </a:p>
@@ -2312,7 +2312,7 @@
           <a:p>
             <a:fld id="{1D8BD707-D9CF-40AE-B4C6-C98DA3205C09}" type="datetimeFigureOut">
               <a:rPr lang="en-US"/>
-              <a:t>6/29/26</a:t>
+              <a:t>6/30/26</a:t>
             </a:fld>
             <a:endParaRPr lang="en-US"/>
           </a:p>
@@ -2982,8 +2982,8 @@
         </p:blipFill>
         <p:spPr>
           <a:xfrm>
-            <a:off x="828000" y="1440000"/>
-            <a:ext cx="5904000" cy="2520000"/>
+            <a:off x="828000" y="1259999"/>
+            <a:ext cx="5904000" cy="3093720"/>
           </a:xfrm>
           <a:prstGeom prst="roundRect">
             <a:avLst>
@@ -3021,8 +3021,8 @@
         </p:blipFill>
         <p:spPr>
           <a:xfrm>
-            <a:off x="1188000" y="5220000"/>
-            <a:ext cx="3060000" cy="3420000"/>
+            <a:off x="962025" y="5648652"/>
+            <a:ext cx="3886200" cy="2456091"/>
           </a:xfrm>
           <a:prstGeom prst="roundRect">
             <a:avLst>
@@ -3106,7 +3106,7 @@
         <p:spPr>
           <a:xfrm>
             <a:off x="468000" y="4140000"/>
-            <a:ext cx="6624000" cy="900000"/>
+            <a:ext cx="6624000" cy="1200329"/>
           </a:xfrm>
           <a:prstGeom prst="rect">
             <a:avLst/>
@@ -3117,6 +3117,15 @@
             <a:spAutoFit/>
           </a:bodyPr>
           <a:lstStyle/>
+          <a:p>
+            <a:pPr algn="ctr"/>
+            <a:endParaRPr lang="fr-FR" sz="2400" dirty="0">
+              <a:solidFill>
+                <a:srgbClr val="333333"/>
+              </a:solidFill>
+              <a:latin typeface="Poppins"/>
+            </a:endParaRPr>
+          </a:p>
           <a:p>
             <a:pPr algn="ctr"/>
             <a:r>
@@ -3427,8 +3436,8 @@
         </p:blipFill>
         <p:spPr>
           <a:xfrm>
-            <a:off x="647405" y="1694321"/>
-            <a:ext cx="2563713" cy="4114800"/>
+            <a:off x="722311" y="1192289"/>
+            <a:ext cx="5953420" cy="3297493"/>
           </a:xfrm>
           <a:prstGeom prst="roundRect">
             <a:avLst>
@@ -3771,8 +3780,8 @@
         </p:nvSpPr>
         <p:spPr>
           <a:xfrm>
-            <a:off x="3426878" y="1812729"/>
-            <a:ext cx="3462250" cy="2308324"/>
+            <a:off x="519050" y="4782144"/>
+            <a:ext cx="4333938" cy="1938992"/>
           </a:xfrm>
           <a:prstGeom prst="rect">
             <a:avLst/>
@@ -3912,8 +3921,8 @@
         </p:blipFill>
         <p:spPr>
           <a:xfrm>
-            <a:off x="2160000" y="1260000"/>
-            <a:ext cx="3240000" cy="2520000"/>
+            <a:off x="1571625" y="1260000"/>
+            <a:ext cx="4267200" cy="2520000"/>
           </a:xfrm>
           <a:prstGeom prst="roundRect">
             <a:avLst>
@@ -4412,8 +4421,8 @@
         </p:blipFill>
         <p:spPr>
           <a:xfrm>
-            <a:off x="1260000" y="1260000"/>
-            <a:ext cx="5040000" cy="3960000"/>
+            <a:off x="1038226" y="1260001"/>
+            <a:ext cx="5261774" cy="3389750"/>
           </a:xfrm>
           <a:prstGeom prst="roundRect">
             <a:avLst>
@@ -4742,7 +4751,7 @@
         </p:nvSpPr>
         <p:spPr>
           <a:xfrm>
-            <a:off x="468000" y="5580000"/>
+            <a:off x="468000" y="5467639"/>
             <a:ext cx="4227825" cy="830997"/>
           </a:xfrm>
           <a:prstGeom prst="rect">
@@ -5468,8 +5477,8 @@
         </p:nvSpPr>
         <p:spPr>
           <a:xfrm>
-            <a:off x="592319" y="3060000"/>
-            <a:ext cx="5220000" cy="1260000"/>
+            <a:off x="592319" y="3006060"/>
+            <a:ext cx="5040000" cy="1345000"/>
           </a:xfrm>
           <a:prstGeom prst="rect">
             <a:avLst/>
@@ -5485,7 +5494,7 @@
               <a:buNone/>
             </a:pPr>
             <a:r>
-              <a:rPr lang="fr-FR" sz="2000" dirty="0">
+              <a:rPr lang="fr-FR" sz="2400" dirty="0">
                 <a:solidFill>
                   <a:srgbClr val="333333"/>
                 </a:solidFill>
@@ -5496,7 +5505,7 @@
               <a:t>Dans la cour, on peut s'amuser ensemble à des </a:t>
             </a:r>
             <a:r>
-              <a:rPr lang="fr-FR" sz="2000" b="1" dirty="0">
+              <a:rPr lang="fr-FR" sz="2400" b="1" dirty="0">
                 <a:solidFill>
                   <a:srgbClr val="333333"/>
                 </a:solidFill>
@@ -5507,7 +5516,7 @@
               <a:t>jeux sans bousculade</a:t>
             </a:r>
             <a:r>
-              <a:rPr lang="fr-FR" sz="2000" dirty="0">
+              <a:rPr lang="fr-FR" sz="2400" dirty="0">
                 <a:solidFill>
                   <a:srgbClr val="333333"/>
                 </a:solidFill>
@@ -5536,8 +5545,8 @@
         </p:blipFill>
         <p:spPr>
           <a:xfrm>
-            <a:off x="1183280" y="4600682"/>
-            <a:ext cx="5041425" cy="3624554"/>
+            <a:off x="786951" y="4982305"/>
+            <a:ext cx="5853112" cy="3604035"/>
           </a:xfrm>
           <a:prstGeom prst="roundRect">
             <a:avLst>
@@ -5861,7 +5870,7 @@
         </p:nvSpPr>
         <p:spPr>
           <a:xfrm>
-            <a:off x="786951" y="8640000"/>
+            <a:off x="786951" y="9050779"/>
             <a:ext cx="5867400" cy="461665"/>
           </a:xfrm>
           <a:prstGeom prst="rect">
@@ -6008,8 +6017,8 @@
         </p:nvSpPr>
         <p:spPr>
           <a:xfrm>
-            <a:off x="861939" y="5637894"/>
-            <a:ext cx="4773219" cy="2620845"/>
+            <a:off x="914781" y="5771474"/>
+            <a:ext cx="5533644" cy="2620845"/>
           </a:xfrm>
           <a:prstGeom prst="rect">
             <a:avLst/>
@@ -6068,6 +6077,19 @@
               </a:rPr>
               <a:t>C'est important de se sentir entouré.</a:t>
             </a:r>
+          </a:p>
+          <a:p>
+            <a:pPr algn="l">
+              <a:spcBef>
+                <a:spcPts val="400"/>
+              </a:spcBef>
+            </a:pPr>
+            <a:endParaRPr lang="fr-FR" sz="2400" b="1" dirty="0">
+              <a:solidFill>
+                <a:srgbClr val="333333"/>
+              </a:solidFill>
+              <a:latin typeface="Poppins"/>
+            </a:endParaRPr>
           </a:p>
           <a:p>
             <a:pPr algn="l">

</xml_diff>

<commit_message>
Livret enfant : reformuler la diapo SED et renouveler les illustrations repetitives
Le texte "Qu'est-ce que le SED ?" est allege et precise que c'est une difference
genetique gardee toute la vie. Les illustrations collagene-schema et
collagene-bouteille, trop similaires aux autres visuels du livret, sont
remplacees par des versions plus distinctes (chaine de collagene, comparaison
colle forte/molle).

Co-Authored-By: Claude Sonnet 5 <noreply@anthropic.com>
</commit_message>
<xml_diff>
--- a/documents/Livret-SED-enfant-SedOcc.pptx
+++ b/documents/Livret-SED-enfant-SedOcc.pptx
@@ -212,7 +212,7 @@
           <a:p>
             <a:fld id="{A2B3F72A-3E22-47E7-995C-6D9D04600525}" type="datetimeFigureOut">
               <a:rPr lang="fr-FR" smtClean="0"/>
-              <a:t>30/06/2026</a:t>
+              <a:t>09/07/2026</a:t>
             </a:fld>
             <a:endParaRPr lang="fr-FR"/>
           </a:p>
@@ -1372,7 +1372,7 @@
           <a:p>
             <a:fld id="{1D8BD707-D9CF-40AE-B4C6-C98DA3205C09}" type="datetimeFigureOut">
               <a:rPr lang="en-US"/>
-              <a:t>6/30/26</a:t>
+              <a:t>7/9/26</a:t>
             </a:fld>
             <a:endParaRPr lang="en-US"/>
           </a:p>
@@ -1580,7 +1580,7 @@
           <a:p>
             <a:fld id="{1D8BD707-D9CF-40AE-B4C6-C98DA3205C09}" type="datetimeFigureOut">
               <a:rPr lang="en-US"/>
-              <a:t>6/30/26</a:t>
+              <a:t>7/9/26</a:t>
             </a:fld>
             <a:endParaRPr lang="en-US"/>
           </a:p>
@@ -1795,7 +1795,7 @@
           <a:p>
             <a:fld id="{1D8BD707-D9CF-40AE-B4C6-C98DA3205C09}" type="datetimeFigureOut">
               <a:rPr lang="en-US"/>
-              <a:t>6/30/26</a:t>
+              <a:t>7/9/26</a:t>
             </a:fld>
             <a:endParaRPr lang="en-US"/>
           </a:p>
@@ -1944,7 +1944,7 @@
           <a:p>
             <a:fld id="{1D8BD707-D9CF-40AE-B4C6-C98DA3205C09}" type="datetimeFigureOut">
               <a:rPr lang="en-US"/>
-              <a:t>6/30/26</a:t>
+              <a:t>7/9/26</a:t>
             </a:fld>
             <a:endParaRPr lang="en-US"/>
           </a:p>
@@ -2064,7 +2064,7 @@
           <a:p>
             <a:fld id="{1D8BD707-D9CF-40AE-B4C6-C98DA3205C09}" type="datetimeFigureOut">
               <a:rPr lang="en-US"/>
-              <a:t>6/30/26</a:t>
+              <a:t>7/9/26</a:t>
             </a:fld>
             <a:endParaRPr lang="en-US"/>
           </a:p>
@@ -2312,7 +2312,7 @@
           <a:p>
             <a:fld id="{1D8BD707-D9CF-40AE-B4C6-C98DA3205C09}" type="datetimeFigureOut">
               <a:rPr lang="en-US"/>
-              <a:t>6/30/26</a:t>
+              <a:t>7/9/26</a:t>
             </a:fld>
             <a:endParaRPr lang="en-US"/>
           </a:p>
@@ -3021,8 +3021,8 @@
         </p:blipFill>
         <p:spPr>
           <a:xfrm>
-            <a:off x="962025" y="5648652"/>
-            <a:ext cx="3886200" cy="2456091"/>
+            <a:off x="962025" y="5804289"/>
+            <a:ext cx="3886200" cy="2144817"/>
           </a:xfrm>
           <a:prstGeom prst="roundRect">
             <a:avLst>
@@ -3436,8 +3436,8 @@
         </p:blipFill>
         <p:spPr>
           <a:xfrm>
-            <a:off x="722311" y="1192289"/>
-            <a:ext cx="5953420" cy="3297493"/>
+            <a:off x="722311" y="1250981"/>
+            <a:ext cx="5953420" cy="3180109"/>
           </a:xfrm>
           <a:prstGeom prst="roundRect">
             <a:avLst>
@@ -3499,14 +3499,8 @@
                 <a:ea typeface="Calibri" pitchFamily="34" charset="-122"/>
                 <a:cs typeface="Calibri" pitchFamily="34" charset="-120"/>
               </a:rPr>
-              <a:t>Ce n'est pas une maladie contagieuse, c'est une différence.</a:t>
+              <a:t>Ce n'est pas une maladie contagieuse : c'est une différence avec laquelle on naît, et qu'on garde toute sa vie.</a:t>
             </a:r>
-            <a:endParaRPr lang="fr-FR" sz="2400" dirty="0"/>
-          </a:p>
-          <a:p>
-            <a:pPr marL="0" indent="0" algn="l">
-              <a:buNone/>
-            </a:pPr>
             <a:endParaRPr lang="fr-FR" sz="2400" dirty="0"/>
           </a:p>
           <a:p>
@@ -3817,7 +3811,7 @@
                 <a:ea typeface="Calibri" panose="020F0502020204030204" pitchFamily="34" charset="0"/>
                 <a:cs typeface="Calibri" panose="020F0502020204030204" pitchFamily="34" charset="0"/>
               </a:rPr>
-              <a:t>Elle est moins solide ou trop élastique.</a:t>
+              <a:t>Elle est moins solide, ou parfois trop élastique.</a:t>
             </a:r>
             <a:endParaRPr lang="fr-FR" sz="2400" dirty="0">
               <a:latin typeface="Calibri" panose="020F0502020204030204" pitchFamily="34" charset="0"/>
@@ -4199,7 +4193,7 @@
         </p:blipFill>
         <p:spPr>
           <a:xfrm>
-            <a:off x="1122320" y="5982629"/>
+            <a:off x="1122878" y="6120000"/>
             <a:ext cx="1007999" cy="1007999"/>
           </a:xfrm>
           <a:prstGeom prst="rect">
@@ -4421,8 +4415,8 @@
         </p:blipFill>
         <p:spPr>
           <a:xfrm>
-            <a:off x="1038226" y="1260001"/>
-            <a:ext cx="5261774" cy="3389750"/>
+            <a:off x="1343025" y="1547204"/>
+            <a:ext cx="4800601" cy="2883911"/>
           </a:xfrm>
           <a:prstGeom prst="roundRect">
             <a:avLst>
@@ -4612,7 +4606,7 @@
         </p:nvSpPr>
         <p:spPr>
           <a:xfrm>
-            <a:off x="5184546" y="5718537"/>
+            <a:off x="5160988" y="5599726"/>
             <a:ext cx="1295999" cy="1295999"/>
           </a:xfrm>
           <a:prstGeom prst="ellipse">
@@ -4662,7 +4656,7 @@
         </p:blipFill>
         <p:spPr>
           <a:xfrm>
-            <a:off x="5383670" y="5949750"/>
+            <a:off x="5374662" y="5796000"/>
             <a:ext cx="1007999" cy="1007999"/>
           </a:xfrm>
           <a:prstGeom prst="rect">
@@ -4751,7 +4745,7 @@
         </p:nvSpPr>
         <p:spPr>
           <a:xfrm>
-            <a:off x="468000" y="5467639"/>
+            <a:off x="712361" y="5148950"/>
             <a:ext cx="4227825" cy="830997"/>
           </a:xfrm>
           <a:prstGeom prst="rect">
@@ -4943,7 +4937,7 @@
       </p:pic>
       <p:pic>
         <p:nvPicPr>
-          <p:cNvPr id="100" name="Picture 99" descr="image.jpeg"/>
+          <p:cNvPr id="101" name="Picture 100" descr="image.jpeg"/>
           <p:cNvPicPr>
             <a:picLocks noChangeAspect="1"/>
           </p:cNvPicPr>
@@ -4957,8 +4951,8 @@
         </p:blipFill>
         <p:spPr>
           <a:xfrm>
-            <a:off x="720000" y="4209750"/>
-            <a:ext cx="1896000" cy="1872000"/>
+            <a:off x="775973" y="4214827"/>
+            <a:ext cx="2624452" cy="1874574"/>
           </a:xfrm>
           <a:prstGeom prst="roundRect">
             <a:avLst>
@@ -4976,7 +4970,7 @@
       </p:pic>
       <p:pic>
         <p:nvPicPr>
-          <p:cNvPr id="101" name="Picture 100" descr="image.jpeg"/>
+          <p:cNvPr id="102" name="Picture 101" descr="image.jpeg"/>
           <p:cNvPicPr>
             <a:picLocks noChangeAspect="1"/>
           </p:cNvPicPr>
@@ -4990,8 +4984,8 @@
         </p:blipFill>
         <p:spPr>
           <a:xfrm>
-            <a:off x="2822475" y="4220850"/>
-            <a:ext cx="1896000" cy="1872000"/>
+            <a:off x="4238625" y="7163385"/>
+            <a:ext cx="2595825" cy="1914632"/>
           </a:xfrm>
           <a:prstGeom prst="roundRect">
             <a:avLst>
@@ -5009,7 +5003,7 @@
       </p:pic>
       <p:pic>
         <p:nvPicPr>
-          <p:cNvPr id="102" name="Picture 101" descr="image.jpeg"/>
+          <p:cNvPr id="103" name="Picture 102" descr="image.png"/>
           <p:cNvPicPr>
             <a:picLocks noChangeAspect="1"/>
           </p:cNvPicPr>
@@ -5023,8 +5017,8 @@
         </p:blipFill>
         <p:spPr>
           <a:xfrm>
-            <a:off x="4938450" y="4219453"/>
-            <a:ext cx="1896000" cy="1872000"/>
+            <a:off x="2409825" y="5768995"/>
+            <a:ext cx="2550676" cy="1755747"/>
           </a:xfrm>
           <a:prstGeom prst="roundRect">
             <a:avLst>
@@ -5042,7 +5036,7 @@
       </p:pic>
       <p:pic>
         <p:nvPicPr>
-          <p:cNvPr id="103" name="Picture 102" descr="image.png"/>
+          <p:cNvPr id="104" name="Picture 103" descr="image.jpg"/>
           <p:cNvPicPr>
             <a:picLocks noChangeAspect="1"/>
           </p:cNvPicPr>
@@ -5056,8 +5050,8 @@
         </p:blipFill>
         <p:spPr>
           <a:xfrm>
-            <a:off x="720000" y="7004000"/>
-            <a:ext cx="1896000" cy="1872000"/>
+            <a:off x="916190" y="7199865"/>
+            <a:ext cx="2560435" cy="1872000"/>
           </a:xfrm>
           <a:prstGeom prst="roundRect">
             <a:avLst>
@@ -5075,7 +5069,7 @@
       </p:pic>
       <p:pic>
         <p:nvPicPr>
-          <p:cNvPr id="104" name="Picture 103" descr="image.jpg"/>
+          <p:cNvPr id="105" name="Picture 104" descr="image.jpg"/>
           <p:cNvPicPr>
             <a:picLocks noChangeAspect="1"/>
           </p:cNvPicPr>
@@ -5089,41 +5083,8 @@
         </p:blipFill>
         <p:spPr>
           <a:xfrm>
-            <a:off x="2832000" y="7055750"/>
-            <a:ext cx="1896000" cy="1872000"/>
-          </a:xfrm>
-          <a:prstGeom prst="roundRect">
-            <a:avLst>
-              <a:gd name="adj" fmla="val 3000"/>
-            </a:avLst>
-          </a:prstGeom>
-          <a:effectLst>
-            <a:outerShdw blurRad="76200" dist="38100" dir="5400000" algn="t" rotWithShape="0">
-              <a:srgbClr val="8B1A2B">
-                <a:alpha val="22000"/>
-              </a:srgbClr>
-            </a:outerShdw>
-          </a:effectLst>
-        </p:spPr>
-      </p:pic>
-      <p:pic>
-        <p:nvPicPr>
-          <p:cNvPr id="105" name="Picture 104" descr="image.jpg"/>
-          <p:cNvPicPr>
-            <a:picLocks noChangeAspect="1"/>
-          </p:cNvPicPr>
-          <p:nvPr/>
-        </p:nvPicPr>
-        <p:blipFill>
-          <a:blip r:embed="rId10"/>
-          <a:stretch>
-            <a:fillRect/>
-          </a:stretch>
-        </p:blipFill>
-        <p:spPr>
-          <a:xfrm>
-            <a:off x="4944000" y="7092000"/>
-            <a:ext cx="1896000" cy="1872000"/>
+            <a:off x="4162425" y="4222027"/>
+            <a:ext cx="2672025" cy="1872000"/>
           </a:xfrm>
           <a:prstGeom prst="roundRect">
             <a:avLst>
@@ -5295,7 +5256,7 @@
           <p:nvPr/>
         </p:nvPicPr>
         <p:blipFill>
-          <a:blip r:embed="rId11"/>
+          <a:blip r:embed="rId10"/>
           <a:stretch>
             <a:fillRect/>
           </a:stretch>
@@ -5545,8 +5506,8 @@
         </p:blipFill>
         <p:spPr>
           <a:xfrm>
-            <a:off x="786951" y="4982305"/>
-            <a:ext cx="5853112" cy="3604035"/>
+            <a:off x="786951" y="5096550"/>
+            <a:ext cx="5853112" cy="3211241"/>
           </a:xfrm>
           <a:prstGeom prst="roundRect">
             <a:avLst>

</xml_diff>

<commit_message>
Livret : mettre a jour le PDF telechargeable avec les dernieres retouches
</commit_message>
<xml_diff>
--- a/documents/Livret-SED-enfant-SedOcc.pptx
+++ b/documents/Livret-SED-enfant-SedOcc.pptx
@@ -212,7 +212,7 @@
           <a:p>
             <a:fld id="{A2B3F72A-3E22-47E7-995C-6D9D04600525}" type="datetimeFigureOut">
               <a:rPr lang="fr-FR" smtClean="0"/>
-              <a:t>09/07/2026</a:t>
+              <a:t>13/07/2026</a:t>
             </a:fld>
             <a:endParaRPr lang="fr-FR"/>
           </a:p>
@@ -1372,7 +1372,7 @@
           <a:p>
             <a:fld id="{1D8BD707-D9CF-40AE-B4C6-C98DA3205C09}" type="datetimeFigureOut">
               <a:rPr lang="en-US"/>
-              <a:t>7/9/26</a:t>
+              <a:t>7/13/26</a:t>
             </a:fld>
             <a:endParaRPr lang="en-US"/>
           </a:p>
@@ -1580,7 +1580,7 @@
           <a:p>
             <a:fld id="{1D8BD707-D9CF-40AE-B4C6-C98DA3205C09}" type="datetimeFigureOut">
               <a:rPr lang="en-US"/>
-              <a:t>7/9/26</a:t>
+              <a:t>7/13/26</a:t>
             </a:fld>
             <a:endParaRPr lang="en-US"/>
           </a:p>
@@ -1795,7 +1795,7 @@
           <a:p>
             <a:fld id="{1D8BD707-D9CF-40AE-B4C6-C98DA3205C09}" type="datetimeFigureOut">
               <a:rPr lang="en-US"/>
-              <a:t>7/9/26</a:t>
+              <a:t>7/13/26</a:t>
             </a:fld>
             <a:endParaRPr lang="en-US"/>
           </a:p>
@@ -1944,7 +1944,7 @@
           <a:p>
             <a:fld id="{1D8BD707-D9CF-40AE-B4C6-C98DA3205C09}" type="datetimeFigureOut">
               <a:rPr lang="en-US"/>
-              <a:t>7/9/26</a:t>
+              <a:t>7/13/26</a:t>
             </a:fld>
             <a:endParaRPr lang="en-US"/>
           </a:p>
@@ -2064,7 +2064,7 @@
           <a:p>
             <a:fld id="{1D8BD707-D9CF-40AE-B4C6-C98DA3205C09}" type="datetimeFigureOut">
               <a:rPr lang="en-US"/>
-              <a:t>7/9/26</a:t>
+              <a:t>7/13/26</a:t>
             </a:fld>
             <a:endParaRPr lang="en-US"/>
           </a:p>
@@ -2312,7 +2312,7 @@
           <a:p>
             <a:fld id="{1D8BD707-D9CF-40AE-B4C6-C98DA3205C09}" type="datetimeFigureOut">
               <a:rPr lang="en-US"/>
-              <a:t>7/9/26</a:t>
+              <a:t>7/13/26</a:t>
             </a:fld>
             <a:endParaRPr lang="en-US"/>
           </a:p>
@@ -2730,7 +2730,7 @@
         </p:blipFill>
         <p:spPr>
           <a:xfrm>
-            <a:off x="1531044" y="4299140"/>
+            <a:off x="1804555" y="4660000"/>
             <a:ext cx="4500000" cy="4500000"/>
           </a:xfrm>
           <a:prstGeom prst="roundRect">
@@ -2982,47 +2982,8 @@
         </p:blipFill>
         <p:spPr>
           <a:xfrm>
-            <a:off x="828000" y="1259999"/>
-            <a:ext cx="5904000" cy="3093720"/>
-          </a:xfrm>
-          <a:prstGeom prst="roundRect">
-            <a:avLst>
-              <a:gd name="adj" fmla="val 3000"/>
-            </a:avLst>
-          </a:prstGeom>
-          <a:effectLst>
-            <a:outerShdw blurRad="76200" dist="38100" dir="5400000" algn="t" rotWithShape="0">
-              <a:srgbClr val="8B1A2B">
-                <a:alpha val="22000"/>
-              </a:srgbClr>
-            </a:outerShdw>
-          </a:effectLst>
-        </p:spPr>
-      </p:pic>
-      <p:pic>
-        <p:nvPicPr>
-          <p:cNvPr id="12" name="Picture 3" descr="image.jpg">
-            <a:extLst>
-              <a:ext uri="{FF2B5EF4-FFF2-40B4-BE49-F238E27FC236}">
-                <a16:creationId xmlns:a16="http://schemas.microsoft.com/office/drawing/2014/main" id="{0A4FCFEE-0379-6C4B-A89F-ABA9E58E8E8A}"/>
-              </a:ext>
-            </a:extLst>
-          </p:cNvPr>
-          <p:cNvPicPr>
-            <a:picLocks noChangeAspect="1"/>
-          </p:cNvPicPr>
-          <p:nvPr/>
-        </p:nvPicPr>
-        <p:blipFill>
-          <a:blip r:embed="rId6"/>
-          <a:stretch>
-            <a:fillRect/>
-          </a:stretch>
-        </p:blipFill>
-        <p:spPr>
-          <a:xfrm>
-            <a:off x="962025" y="5804289"/>
-            <a:ext cx="3886200" cy="2144817"/>
+            <a:off x="954670" y="6023282"/>
+            <a:ext cx="3839162" cy="2052809"/>
           </a:xfrm>
           <a:prstGeom prst="roundRect">
             <a:avLst>
@@ -3052,7 +3013,7 @@
         </p:nvSpPr>
         <p:spPr>
           <a:xfrm>
-            <a:off x="468000" y="8820000"/>
+            <a:off x="468000" y="8584940"/>
             <a:ext cx="6624000" cy="900000"/>
           </a:xfrm>
           <a:prstGeom prst="rect">
@@ -3105,7 +3066,7 @@
         </p:nvSpPr>
         <p:spPr>
           <a:xfrm>
-            <a:off x="468000" y="4140000"/>
+            <a:off x="468000" y="4262317"/>
             <a:ext cx="6624000" cy="1200329"/>
           </a:xfrm>
           <a:prstGeom prst="rect">
@@ -3322,6 +3283,36 @@
           <p:nvPr/>
         </p:nvPicPr>
         <p:blipFill>
+          <a:blip r:embed="rId6"/>
+          <a:stretch>
+            <a:fillRect/>
+          </a:stretch>
+        </p:blipFill>
+        <p:spPr>
+          <a:xfrm>
+            <a:off x="5443381" y="6978092"/>
+            <a:ext cx="1007999" cy="1007999"/>
+          </a:xfrm>
+          <a:prstGeom prst="rect">
+            <a:avLst/>
+          </a:prstGeom>
+        </p:spPr>
+      </p:pic>
+      <p:pic>
+        <p:nvPicPr>
+          <p:cNvPr id="14" name="Image 0" descr="unpacked/ppt/media/image_A81BC803.jpg">
+            <a:extLst>
+              <a:ext uri="{FF2B5EF4-FFF2-40B4-BE49-F238E27FC236}">
+                <a16:creationId xmlns:a16="http://schemas.microsoft.com/office/drawing/2014/main" id="{A2A54B0F-A3BF-524B-BF9C-3D15C7F0E626}"/>
+              </a:ext>
+            </a:extLst>
+          </p:cNvPr>
+          <p:cNvPicPr>
+            <a:picLocks noChangeAspect="1"/>
+          </p:cNvPicPr>
+          <p:nvPr/>
+        </p:nvPicPr>
+        <p:blipFill>
           <a:blip r:embed="rId7"/>
           <a:stretch>
             <a:fillRect/>
@@ -3329,12 +3320,21 @@
         </p:blipFill>
         <p:spPr>
           <a:xfrm>
-            <a:off x="5443381" y="6978092"/>
-            <a:ext cx="1007999" cy="1007999"/>
-          </a:xfrm>
-          <a:prstGeom prst="rect">
-            <a:avLst/>
-          </a:prstGeom>
+            <a:off x="954670" y="1331863"/>
+            <a:ext cx="5496710" cy="2936150"/>
+          </a:xfrm>
+          <a:prstGeom prst="roundRect">
+            <a:avLst>
+              <a:gd name="adj" fmla="val 3000"/>
+            </a:avLst>
+          </a:prstGeom>
+          <a:effectLst>
+            <a:outerShdw blurRad="76200" dist="38100" dir="5400000" algn="t" rotWithShape="0">
+              <a:srgbClr val="8B1A2B">
+                <a:alpha val="22000"/>
+              </a:srgbClr>
+            </a:outerShdw>
+          </a:effectLst>
         </p:spPr>
       </p:pic>
     </p:spTree>
@@ -3420,39 +3420,6 @@
           </a:p>
         </p:txBody>
       </p:sp>
-      <p:pic>
-        <p:nvPicPr>
-          <p:cNvPr id="3" name="Image 0" descr="unpacked/ppt/media/image_A81BC803.jpg"/>
-          <p:cNvPicPr>
-            <a:picLocks noChangeAspect="1"/>
-          </p:cNvPicPr>
-          <p:nvPr/>
-        </p:nvPicPr>
-        <p:blipFill>
-          <a:blip r:embed="rId4"/>
-          <a:stretch>
-            <a:fillRect/>
-          </a:stretch>
-        </p:blipFill>
-        <p:spPr>
-          <a:xfrm>
-            <a:off x="722311" y="1250981"/>
-            <a:ext cx="5953420" cy="3180109"/>
-          </a:xfrm>
-          <a:prstGeom prst="roundRect">
-            <a:avLst>
-              <a:gd name="adj" fmla="val 3000"/>
-            </a:avLst>
-          </a:prstGeom>
-          <a:effectLst>
-            <a:outerShdw blurRad="76200" dist="38100" dir="5400000" algn="t" rotWithShape="0">
-              <a:srgbClr val="8B1A2B">
-                <a:alpha val="22000"/>
-              </a:srgbClr>
-            </a:outerShdw>
-          </a:effectLst>
-        </p:spPr>
-      </p:pic>
       <p:sp>
         <p:nvSpPr>
           <p:cNvPr id="4" name="Text 1"/>
@@ -3461,7 +3428,7 @@
         </p:nvSpPr>
         <p:spPr>
           <a:xfrm>
-            <a:off x="457200" y="6600789"/>
+            <a:off x="457200" y="6832546"/>
             <a:ext cx="6647688" cy="2563453"/>
           </a:xfrm>
           <a:prstGeom prst="rect">
@@ -3678,7 +3645,7 @@
           <p:nvPr/>
         </p:nvPicPr>
         <p:blipFill>
-          <a:blip r:embed="rId5"/>
+          <a:blip r:embed="rId4"/>
           <a:stretch>
             <a:fillRect/>
           </a:stretch>
@@ -3746,7 +3713,7 @@
           <p:nvPr/>
         </p:nvPicPr>
         <p:blipFill rotWithShape="1">
-          <a:blip r:embed="rId6"/>
+          <a:blip r:embed="rId5"/>
           <a:srcRect l="9802" t="10888" r="15836" b="19876"/>
           <a:stretch/>
         </p:blipFill>
@@ -3821,6 +3788,45 @@
           </a:p>
         </p:txBody>
       </p:sp>
+      <p:pic>
+        <p:nvPicPr>
+          <p:cNvPr id="13" name="Picture 3" descr="image.jpg">
+            <a:extLst>
+              <a:ext uri="{FF2B5EF4-FFF2-40B4-BE49-F238E27FC236}">
+                <a16:creationId xmlns:a16="http://schemas.microsoft.com/office/drawing/2014/main" id="{ADA3D401-E2F8-EA42-8EC4-6D30C0D4606B}"/>
+              </a:ext>
+            </a:extLst>
+          </p:cNvPr>
+          <p:cNvPicPr>
+            <a:picLocks noChangeAspect="1"/>
+          </p:cNvPicPr>
+          <p:nvPr/>
+        </p:nvPicPr>
+        <p:blipFill>
+          <a:blip r:embed="rId6"/>
+          <a:stretch>
+            <a:fillRect/>
+          </a:stretch>
+        </p:blipFill>
+        <p:spPr>
+          <a:xfrm>
+            <a:off x="966788" y="1344332"/>
+            <a:ext cx="5487214" cy="3028426"/>
+          </a:xfrm>
+          <a:prstGeom prst="roundRect">
+            <a:avLst>
+              <a:gd name="adj" fmla="val 3000"/>
+            </a:avLst>
+          </a:prstGeom>
+          <a:effectLst>
+            <a:outerShdw blurRad="76200" dist="38100" dir="5400000" algn="t" rotWithShape="0">
+              <a:srgbClr val="8B1A2B">
+                <a:alpha val="22000"/>
+              </a:srgbClr>
+            </a:outerShdw>
+          </a:effectLst>
+        </p:spPr>
+      </p:pic>
     </p:spTree>
   </p:cSld>
   <p:clrMapOvr>
@@ -4415,8 +4421,8 @@
         </p:blipFill>
         <p:spPr>
           <a:xfrm>
-            <a:off x="1343025" y="1547204"/>
-            <a:ext cx="4800601" cy="2883911"/>
+            <a:off x="943550" y="1527950"/>
+            <a:ext cx="5672899" cy="3252672"/>
           </a:xfrm>
           <a:prstGeom prst="roundRect">
             <a:avLst>
@@ -4745,7 +4751,7 @@
         </p:nvSpPr>
         <p:spPr>
           <a:xfrm>
-            <a:off x="712361" y="5148950"/>
+            <a:off x="778704" y="5451229"/>
             <a:ext cx="4227825" cy="830997"/>
           </a:xfrm>
           <a:prstGeom prst="rect">
@@ -5953,8 +5959,8 @@
         </p:blipFill>
         <p:spPr>
           <a:xfrm>
-            <a:off x="914781" y="1188720"/>
-            <a:ext cx="5733288" cy="4114800"/>
+            <a:off x="914781" y="1490708"/>
+            <a:ext cx="5733288" cy="3657796"/>
           </a:xfrm>
           <a:prstGeom prst="roundRect">
             <a:avLst>

</xml_diff>

<commit_message>
Livret enfant : ajouter 4 nouvelles pages interactives
Ajout de 4 pages avant l'encart "Pour tes parents" (qui devient sa propre
page/diapositive) : jauge de super-energie (pile verte/orange/rouge),
equipements de super-heros (boucliers/armure/propulseurs), pacte des
supers copains façon diplome avec ligne de signature, et une silhouette
a colorier. Meme mise en page, polices et couleurs que le reste du
livret, sur le site (HTML/CSS) et dans le PowerPoint.

Co-Authored-By: Claude Sonnet 5 <noreply@anthropic.com>
</commit_message>
<xml_diff>
--- a/documents/Livret-SED-enfant-SedOcc.pptx
+++ b/documents/Livret-SED-enfant-SedOcc.pptx
@@ -16,6 +16,11 @@
     <p:sldId id="260" r:id="rId7"/>
     <p:sldId id="261" r:id="rId8"/>
     <p:sldId id="262" r:id="rId9"/>
+    <p:sldId id="266" r:id="rId16"/>
+    <p:sldId id="267" r:id="rId17"/>
+    <p:sldId id="268" r:id="rId18"/>
+    <p:sldId id="269" r:id="rId19"/>
+    <p:sldId id="265" r:id="rId15"/>
   </p:sldIdLst>
   <p:sldSz cx="7562850" cy="10688638"/>
   <p:notesSz cx="10688638" cy="7562850"/>
@@ -2822,6 +2827,2496 @@
 </p:sld>
 </file>
 
+<file path=ppt/slides/slide10.xml><?xml version="1.0" encoding="utf-8"?>
+<p:sld xmlns:a="http://schemas.openxmlformats.org/drawingml/2006/main" xmlns:r="http://schemas.openxmlformats.org/officeDocument/2006/relationships" xmlns:p="http://schemas.openxmlformats.org/presentationml/2006/main">
+  <p:cSld name="Slide 2">
+    <p:bg>
+      <p:bgPr>
+        <a:blipFill dpi="0" rotWithShape="1">
+          <a:blip r:embed="rId3">
+            <a:lum/>
+          </a:blip>
+          <a:srcRect/>
+          <a:stretch>
+            <a:fillRect/>
+          </a:stretch>
+        </a:blipFill>
+        <a:effectLst/>
+      </p:bgPr>
+    </p:bg>
+    <p:spTree>
+      <p:nvGrpSpPr>
+        <p:cNvPr id="1" name=""/>
+        <p:cNvGrpSpPr/>
+        <p:nvPr/>
+      </p:nvGrpSpPr>
+      <p:grpSpPr>
+        <a:xfrm>
+          <a:off x="0" y="0"/>
+          <a:ext cx="0" cy="0"/>
+          <a:chOff x="0" y="0"/>
+          <a:chExt cx="0" cy="0"/>
+        </a:xfrm>
+      </p:grpSpPr>
+      <p:sp>
+        <p:nvSpPr>
+          <p:cNvPr id="2" name="Text 0"/>
+          <p:cNvSpPr/>
+          <p:nvPr/>
+        </p:nvSpPr>
+        <p:spPr>
+          <a:xfrm>
+            <a:off x="457200" y="365760"/>
+            <a:ext cx="6647688" cy="640080"/>
+          </a:xfrm>
+          <a:prstGeom prst="rect">
+            <a:avLst/>
+          </a:prstGeom>
+          <a:noFill/>
+          <a:ln/>
+        </p:spPr>
+        <p:txBody>
+          <a:bodyPr wrap="square" lIns="0" tIns="0" rIns="0" bIns="0" rtlCol="0" anchor="ctr"/>
+          <a:lstStyle/>
+          <a:p>
+            <a:pPr marL="0" indent="0" algn="ctr">
+              <a:buNone/>
+            </a:pPr>
+            <a:r>
+              <a:rPr lang="fr-FR" sz="2800" b="1" dirty="0">
+                <a:solidFill>
+                  <a:srgbClr val="8B1A2B"/>
+                </a:solidFill>
+                <a:latin typeface="Poppins" pitchFamily="34" charset="0"/>
+                <a:ea typeface="Calibri" pitchFamily="34" charset="-122"/>
+                <a:cs typeface="Calibri" pitchFamily="34" charset="-120"/>
+              </a:rPr>
+              <a:t>Mon niveau de super-énergie !</a:t>
+            </a:r>
+            <a:endParaRPr lang="fr-FR" sz="2800" dirty="0"/>
+          </a:p>
+        </p:txBody>
+      </p:sp>
+      <p:sp>
+        <p:nvSpPr>
+          <p:cNvPr id="99" name="Footer"/>
+          <p:cNvSpPr/>
+          <p:nvPr/>
+        </p:nvSpPr>
+        <p:spPr>
+          <a:xfrm>
+            <a:off x="500000" y="10300000"/>
+            <a:ext cx="6562850" cy="300000"/>
+          </a:xfrm>
+          <a:prstGeom prst="rect">
+            <a:avLst/>
+          </a:prstGeom>
+          <a:noFill/>
+          <a:ln/>
+        </p:spPr>
+        <p:txBody>
+          <a:bodyPr wrap="square" lIns="0" tIns="0" rIns="0" bIns="0" rtlCol="0" anchor="ctr"/>
+          <a:lstStyle/>
+          <a:p>
+            <a:pPr marL="0" indent="0" algn="ctr">
+              <a:buNone/>
+            </a:pPr>
+            <a:r>
+              <a:rPr lang="fr-FR" sz="1000" i="1">
+                <a:solidFill>
+                  <a:srgbClr val="666666"/>
+                </a:solidFill>
+                <a:latin typeface="Poppins" pitchFamily="34" charset="0"/>
+                <a:ea typeface="Calibri" pitchFamily="34" charset="0"/>
+                <a:cs typeface="Calibri" pitchFamily="34" charset="0"/>
+              </a:rPr>
+              <a:t>Fait par l’association Sed’Occ France 04/2026</a:t>
+            </a:r>
+          </a:p>
+        </p:txBody>
+      </p:sp>
+      <p:pic>
+        <p:nvPicPr>
+          <p:cNvPr id="9" name="Image 8">
+            <a:extLst>
+              <a:ext uri="{FF2B5EF4-FFF2-40B4-BE49-F238E27FC236}">
+                <a16:creationId xmlns:a16="http://schemas.microsoft.com/office/drawing/2014/main" id="{1272B92B-21E4-464F-9F8E-4A62B1E16185}"/>
+              </a:ext>
+            </a:extLst>
+          </p:cNvPr>
+          <p:cNvPicPr>
+            <a:picLocks noChangeAspect="1"/>
+          </p:cNvPicPr>
+          <p:nvPr/>
+        </p:nvPicPr>
+        <p:blipFill rotWithShape="1">
+          <a:blip r:embed="rId5"/>
+          <a:srcRect l="9802" t="10888" r="15836" b="19876"/>
+          <a:stretch/>
+        </p:blipFill>
+        <p:spPr>
+          <a:xfrm>
+            <a:off x="6300000" y="9540000"/>
+            <a:ext cx="1080000" cy="1007999"/>
+          </a:xfrm>
+          <a:prstGeom prst="rect">
+            <a:avLst/>
+          </a:prstGeom>
+        </p:spPr>
+      </p:pic>
+      <p:sp>
+        <p:nvSpPr>
+          <p:cNvPr id="50" name="Text 50"/>
+          <p:cNvSpPr/>
+          <p:nvPr/>
+        </p:nvSpPr>
+        <p:spPr>
+          <a:xfrm>
+            <a:off x="457200" y="1080000"/>
+            <a:ext cx="6647688" cy="1700000"/>
+          </a:xfrm>
+          <a:prstGeom prst="rect">
+            <a:avLst/>
+          </a:prstGeom>
+          <a:noFill/>
+          <a:ln/>
+        </p:spPr>
+        <p:txBody>
+          <a:bodyPr wrap="square" lIns="0" tIns="0" rIns="0" bIns="0" rtlCol="0" anchor="t"/>
+          <a:lstStyle/>
+          <a:p>
+            <a:pPr marL="0" indent="0" algn="ctr">
+              <a:buNone/>
+            </a:pPr>
+            <a:r>
+              <a:rPr lang="fr-FR" sz="1800" b="0" dirty="0">
+                <a:solidFill>
+                  <a:srgbClr val="333333"/>
+                </a:solidFill>
+                <a:latin typeface="Poppins"/>
+              </a:rPr>
+              <a:t>Comme on l'a vu, à cause de la colle lâche, le corps fait plus d'efforts et la grande batterie peut se vider plus vite. C'est normal !</a:t>
+            </a:r>
+          </a:p>
+          <a:p>
+            <a:pPr marL="0" indent="0" algn="ctr">
+              <a:buNone/>
+            </a:pPr>
+            <a:r>
+              <a:rPr lang="fr-FR" sz="1800" b="0" dirty="0">
+                <a:solidFill>
+                  <a:srgbClr val="333333"/>
+                </a:solidFill>
+                <a:latin typeface="Poppins"/>
+              </a:rPr>
+              <a:t>Parfois, quand la batterie est à plat ou que les alarmes sonnent, tu as le droit de te sentir triste ou en colère. L'important, c'est d'apprendre à écouter ton corps.</a:t>
+            </a:r>
+          </a:p>
+          <a:p>
+            <a:pPr marL="0" indent="0" algn="ctr">
+              <a:buNone/>
+            </a:pPr>
+            <a:r>
+              <a:rPr lang="fr-FR" sz="1800" b="1" dirty="0">
+                <a:solidFill>
+                  <a:srgbClr val="8B1A2B"/>
+                </a:solidFill>
+                <a:latin typeface="Poppins"/>
+              </a:rPr>
+              <a:t>Montre à tes parents ou à tes copains où en est ta batterie aujourd'hui :</a:t>
+            </a:r>
+          </a:p>
+        </p:txBody>
+      </p:sp>
+      <p:sp>
+        <p:nvSpPr>
+          <p:cNvPr id="61" name="Card 61"/>
+          <p:cNvSpPr/>
+          <p:nvPr/>
+        </p:nvSpPr>
+        <p:spPr>
+          <a:xfrm>
+            <a:off x="457200" y="3350000"/>
+            <a:ext cx="2050000" cy="4400000"/>
+          </a:xfrm>
+          <a:prstGeom prst="roundRect">
+            <a:avLst>
+              <a:gd name="adj" fmla="val 6000"/>
+            </a:avLst>
+          </a:prstGeom>
+          <a:solidFill>
+            <a:srgbClr val="FFFFFF"/>
+          </a:solidFill>
+          <a:ln w="12700">
+            <a:solidFill>
+              <a:srgbClr val="8B1A2B">
+                <a:alpha val="15000"/>
+              </a:srgbClr>
+            </a:solidFill>
+          </a:ln>
+          <a:effectLst>
+            <a:outerShdw blurRad="60000" dist="20000" dir="5400000" algn="t" rotWithShape="0">
+              <a:srgbClr val="8B1A2B">
+                <a:alpha val="18000"/>
+              </a:srgbClr>
+            </a:outerShdw>
+          </a:effectLst>
+        </p:spPr>
+        <p:txBody>
+          <a:bodyPr/>
+          <a:lstStyle/>
+          <a:p>
+            <a:endParaRPr lang="fr-FR"/>
+          </a:p>
+        </p:txBody>
+      </p:sp>
+      <p:sp>
+        <p:nvSpPr>
+          <p:cNvPr id="62" name="BattBody 62"/>
+          <p:cNvSpPr/>
+          <p:nvPr/>
+        </p:nvSpPr>
+        <p:spPr>
+          <a:xfrm>
+            <a:off x="1122200" y="3610000"/>
+            <a:ext cx="720000" cy="380000"/>
+          </a:xfrm>
+          <a:prstGeom prst="roundRect">
+            <a:avLst>
+              <a:gd name="adj" fmla="val 15000"/>
+            </a:avLst>
+          </a:prstGeom>
+          <a:noFill/>
+          <a:ln w="28575">
+            <a:solidFill>
+              <a:srgbClr val="8B1A2B"/>
+            </a:solidFill>
+          </a:ln>
+        </p:spPr>
+        <p:txBody>
+          <a:bodyPr/>
+          <a:lstStyle/>
+          <a:p>
+            <a:endParaRPr lang="fr-FR"/>
+          </a:p>
+        </p:txBody>
+      </p:sp>
+      <p:sp>
+        <p:nvSpPr>
+          <p:cNvPr id="63" name="BattNub 63"/>
+          <p:cNvSpPr/>
+          <p:nvPr/>
+        </p:nvSpPr>
+        <p:spPr>
+          <a:xfrm>
+            <a:off x="1842200" y="3740000"/>
+            <a:ext cx="45000" cy="120000"/>
+          </a:xfrm>
+          <a:prstGeom prst="rect">
+            <a:avLst/>
+          </a:prstGeom>
+          <a:solidFill>
+            <a:srgbClr val="8B1A2B"/>
+          </a:solidFill>
+          <a:ln>
+            <a:noFill/>
+          </a:ln>
+        </p:spPr>
+        <p:txBody>
+          <a:bodyPr/>
+          <a:lstStyle/>
+          <a:p>
+            <a:endParaRPr lang="fr-FR"/>
+          </a:p>
+        </p:txBody>
+      </p:sp>
+      <p:sp>
+        <p:nvSpPr>
+          <p:cNvPr id="64" name="BattFill 64"/>
+          <p:cNvSpPr/>
+          <p:nvPr/>
+        </p:nvSpPr>
+        <p:spPr>
+          <a:xfrm>
+            <a:off x="1142200" y="3630000"/>
+            <a:ext cx="680000" cy="340000"/>
+          </a:xfrm>
+          <a:prstGeom prst="roundRect">
+            <a:avLst>
+              <a:gd name="adj" fmla="val 15000"/>
+            </a:avLst>
+          </a:prstGeom>
+          <a:solidFill>
+            <a:srgbClr val="5CA86B"/>
+          </a:solidFill>
+          <a:ln>
+            <a:noFill/>
+          </a:ln>
+        </p:spPr>
+        <p:txBody>
+          <a:bodyPr/>
+          <a:lstStyle/>
+          <a:p>
+            <a:endParaRPr lang="fr-FR"/>
+          </a:p>
+        </p:txBody>
+      </p:sp>
+      <p:sp>
+        <p:nvSpPr>
+          <p:cNvPr id="65" name="Text 65"/>
+          <p:cNvSpPr/>
+          <p:nvPr/>
+        </p:nvSpPr>
+        <p:spPr>
+          <a:xfrm>
+            <a:off x="507200" y="4110000"/>
+            <a:ext cx="1950000" cy="700000"/>
+          </a:xfrm>
+          <a:prstGeom prst="rect">
+            <a:avLst/>
+          </a:prstGeom>
+          <a:noFill/>
+          <a:ln/>
+        </p:spPr>
+        <p:txBody>
+          <a:bodyPr wrap="square" lIns="0" tIns="0" rIns="0" bIns="0" rtlCol="0" anchor="t"/>
+          <a:lstStyle/>
+          <a:p>
+            <a:pPr marL="0" indent="0" algn="ctr">
+              <a:buNone/>
+            </a:pPr>
+            <a:r>
+              <a:rPr lang="fr-FR" sz="1500" b="1" dirty="0">
+                <a:solidFill>
+                  <a:srgbClr val="8B1A2B"/>
+                </a:solidFill>
+                <a:latin typeface="Poppins"/>
+              </a:rPr>
+              <a:t>Pile Verte</a:t>
+            </a:r>
+          </a:p>
+          <a:p>
+            <a:pPr marL="0" indent="0" algn="ctr">
+              <a:buNone/>
+            </a:pPr>
+            <a:r>
+              <a:rPr lang="fr-FR" sz="1500" b="1" dirty="0">
+                <a:solidFill>
+                  <a:srgbClr val="8B1A2B"/>
+                </a:solidFill>
+                <a:latin typeface="Poppins"/>
+              </a:rPr>
+              <a:t>(Pleine)</a:t>
+            </a:r>
+          </a:p>
+        </p:txBody>
+      </p:sp>
+      <p:sp>
+        <p:nvSpPr>
+          <p:cNvPr id="66" name="Text 66"/>
+          <p:cNvSpPr/>
+          <p:nvPr/>
+        </p:nvSpPr>
+        <p:spPr>
+          <a:xfrm>
+            <a:off x="537200" y="4890000"/>
+            <a:ext cx="1890000" cy="2860000"/>
+          </a:xfrm>
+          <a:prstGeom prst="rect">
+            <a:avLst/>
+          </a:prstGeom>
+          <a:noFill/>
+          <a:ln/>
+        </p:spPr>
+        <p:txBody>
+          <a:bodyPr wrap="square" lIns="0" tIns="0" rIns="0" bIns="0" rtlCol="0" anchor="t"/>
+          <a:lstStyle/>
+          <a:p>
+            <a:pPr marL="0" indent="0" algn="ctr">
+              <a:buNone/>
+            </a:pPr>
+            <a:r>
+              <a:rPr lang="fr-FR" sz="1150" b="0" dirty="0">
+                <a:solidFill>
+                  <a:srgbClr val="333333"/>
+                </a:solidFill>
+                <a:latin typeface="Poppins"/>
+              </a:rPr>
+              <a:t>Je suis en pleine forme ! Je peux jouer, mais je fais attention à ma colle magique.</a:t>
+            </a:r>
+          </a:p>
+        </p:txBody>
+      </p:sp>
+      <p:sp>
+        <p:nvSpPr>
+          <p:cNvPr id="67" name="Card 67"/>
+          <p:cNvSpPr/>
+          <p:nvPr/>
+        </p:nvSpPr>
+        <p:spPr>
+          <a:xfrm>
+            <a:off x="2756044" y="3350000"/>
+            <a:ext cx="2050000" cy="4400000"/>
+          </a:xfrm>
+          <a:prstGeom prst="roundRect">
+            <a:avLst>
+              <a:gd name="adj" fmla="val 6000"/>
+            </a:avLst>
+          </a:prstGeom>
+          <a:solidFill>
+            <a:srgbClr val="FFFFFF"/>
+          </a:solidFill>
+          <a:ln w="12700">
+            <a:solidFill>
+              <a:srgbClr val="8B1A2B">
+                <a:alpha val="15000"/>
+              </a:srgbClr>
+            </a:solidFill>
+          </a:ln>
+          <a:effectLst>
+            <a:outerShdw blurRad="60000" dist="20000" dir="5400000" algn="t" rotWithShape="0">
+              <a:srgbClr val="8B1A2B">
+                <a:alpha val="18000"/>
+              </a:srgbClr>
+            </a:outerShdw>
+          </a:effectLst>
+        </p:spPr>
+        <p:txBody>
+          <a:bodyPr/>
+          <a:lstStyle/>
+          <a:p>
+            <a:endParaRPr lang="fr-FR"/>
+          </a:p>
+        </p:txBody>
+      </p:sp>
+      <p:sp>
+        <p:nvSpPr>
+          <p:cNvPr id="68" name="BattBody 68"/>
+          <p:cNvSpPr/>
+          <p:nvPr/>
+        </p:nvSpPr>
+        <p:spPr>
+          <a:xfrm>
+            <a:off x="3421044" y="3610000"/>
+            <a:ext cx="720000" cy="380000"/>
+          </a:xfrm>
+          <a:prstGeom prst="roundRect">
+            <a:avLst>
+              <a:gd name="adj" fmla="val 15000"/>
+            </a:avLst>
+          </a:prstGeom>
+          <a:noFill/>
+          <a:ln w="28575">
+            <a:solidFill>
+              <a:srgbClr val="8B1A2B"/>
+            </a:solidFill>
+          </a:ln>
+        </p:spPr>
+        <p:txBody>
+          <a:bodyPr/>
+          <a:lstStyle/>
+          <a:p>
+            <a:endParaRPr lang="fr-FR"/>
+          </a:p>
+        </p:txBody>
+      </p:sp>
+      <p:sp>
+        <p:nvSpPr>
+          <p:cNvPr id="69" name="BattNub 69"/>
+          <p:cNvSpPr/>
+          <p:nvPr/>
+        </p:nvSpPr>
+        <p:spPr>
+          <a:xfrm>
+            <a:off x="4141044" y="3740000"/>
+            <a:ext cx="45000" cy="120000"/>
+          </a:xfrm>
+          <a:prstGeom prst="rect">
+            <a:avLst/>
+          </a:prstGeom>
+          <a:solidFill>
+            <a:srgbClr val="8B1A2B"/>
+          </a:solidFill>
+          <a:ln>
+            <a:noFill/>
+          </a:ln>
+        </p:spPr>
+        <p:txBody>
+          <a:bodyPr/>
+          <a:lstStyle/>
+          <a:p>
+            <a:endParaRPr lang="fr-FR"/>
+          </a:p>
+        </p:txBody>
+      </p:sp>
+      <p:sp>
+        <p:nvSpPr>
+          <p:cNvPr id="70" name="BattFill 70"/>
+          <p:cNvSpPr/>
+          <p:nvPr/>
+        </p:nvSpPr>
+        <p:spPr>
+          <a:xfrm>
+            <a:off x="3441044" y="3630000"/>
+            <a:ext cx="408000" cy="340000"/>
+          </a:xfrm>
+          <a:prstGeom prst="roundRect">
+            <a:avLst>
+              <a:gd name="adj" fmla="val 15000"/>
+            </a:avLst>
+          </a:prstGeom>
+          <a:solidFill>
+            <a:srgbClr val="E8963D"/>
+          </a:solidFill>
+          <a:ln>
+            <a:noFill/>
+          </a:ln>
+        </p:spPr>
+        <p:txBody>
+          <a:bodyPr/>
+          <a:lstStyle/>
+          <a:p>
+            <a:endParaRPr lang="fr-FR"/>
+          </a:p>
+        </p:txBody>
+      </p:sp>
+      <p:sp>
+        <p:nvSpPr>
+          <p:cNvPr id="71" name="Text 71"/>
+          <p:cNvSpPr/>
+          <p:nvPr/>
+        </p:nvSpPr>
+        <p:spPr>
+          <a:xfrm>
+            <a:off x="2806044" y="4110000"/>
+            <a:ext cx="1950000" cy="700000"/>
+          </a:xfrm>
+          <a:prstGeom prst="rect">
+            <a:avLst/>
+          </a:prstGeom>
+          <a:noFill/>
+          <a:ln/>
+        </p:spPr>
+        <p:txBody>
+          <a:bodyPr wrap="square" lIns="0" tIns="0" rIns="0" bIns="0" rtlCol="0" anchor="t"/>
+          <a:lstStyle/>
+          <a:p>
+            <a:pPr marL="0" indent="0" algn="ctr">
+              <a:buNone/>
+            </a:pPr>
+            <a:r>
+              <a:rPr lang="fr-FR" sz="1500" b="1" dirty="0">
+                <a:solidFill>
+                  <a:srgbClr val="8B1A2B"/>
+                </a:solidFill>
+                <a:latin typeface="Poppins"/>
+              </a:rPr>
+              <a:t>Pile Orange</a:t>
+            </a:r>
+          </a:p>
+          <a:p>
+            <a:pPr marL="0" indent="0" algn="ctr">
+              <a:buNone/>
+            </a:pPr>
+            <a:r>
+              <a:rPr lang="fr-FR" sz="1500" b="1" dirty="0">
+                <a:solidFill>
+                  <a:srgbClr val="8B1A2B"/>
+                </a:solidFill>
+                <a:latin typeface="Poppins"/>
+              </a:rPr>
+              <a:t>(Moyenne)</a:t>
+            </a:r>
+          </a:p>
+        </p:txBody>
+      </p:sp>
+      <p:sp>
+        <p:nvSpPr>
+          <p:cNvPr id="72" name="Text 72"/>
+          <p:cNvSpPr/>
+          <p:nvPr/>
+        </p:nvSpPr>
+        <p:spPr>
+          <a:xfrm>
+            <a:off x="2836044" y="4890000"/>
+            <a:ext cx="1890000" cy="2860000"/>
+          </a:xfrm>
+          <a:prstGeom prst="rect">
+            <a:avLst/>
+          </a:prstGeom>
+          <a:noFill/>
+          <a:ln/>
+        </p:spPr>
+        <p:txBody>
+          <a:bodyPr wrap="square" lIns="0" tIns="0" rIns="0" bIns="0" rtlCol="0" anchor="t"/>
+          <a:lstStyle/>
+          <a:p>
+            <a:pPr marL="0" indent="0" algn="ctr">
+              <a:buNone/>
+            </a:pPr>
+            <a:r>
+              <a:rPr lang="fr-FR" sz="1150" b="0" dirty="0">
+                <a:solidFill>
+                  <a:srgbClr val="333333"/>
+                </a:solidFill>
+                <a:latin typeface="Poppins"/>
+              </a:rPr>
+              <a:t>Ma batterie baisse un peu... J'ai besoin de faire une pause ou de choisir un jeu calme, comme le dessin.</a:t>
+            </a:r>
+          </a:p>
+        </p:txBody>
+      </p:sp>
+      <p:sp>
+        <p:nvSpPr>
+          <p:cNvPr id="73" name="Card 73"/>
+          <p:cNvSpPr/>
+          <p:nvPr/>
+        </p:nvSpPr>
+        <p:spPr>
+          <a:xfrm>
+            <a:off x="5054888" y="3350000"/>
+            <a:ext cx="2050000" cy="4400000"/>
+          </a:xfrm>
+          <a:prstGeom prst="roundRect">
+            <a:avLst>
+              <a:gd name="adj" fmla="val 6000"/>
+            </a:avLst>
+          </a:prstGeom>
+          <a:solidFill>
+            <a:srgbClr val="FFFFFF"/>
+          </a:solidFill>
+          <a:ln w="12700">
+            <a:solidFill>
+              <a:srgbClr val="8B1A2B">
+                <a:alpha val="15000"/>
+              </a:srgbClr>
+            </a:solidFill>
+          </a:ln>
+          <a:effectLst>
+            <a:outerShdw blurRad="60000" dist="20000" dir="5400000" algn="t" rotWithShape="0">
+              <a:srgbClr val="8B1A2B">
+                <a:alpha val="18000"/>
+              </a:srgbClr>
+            </a:outerShdw>
+          </a:effectLst>
+        </p:spPr>
+        <p:txBody>
+          <a:bodyPr/>
+          <a:lstStyle/>
+          <a:p>
+            <a:endParaRPr lang="fr-FR"/>
+          </a:p>
+        </p:txBody>
+      </p:sp>
+      <p:sp>
+        <p:nvSpPr>
+          <p:cNvPr id="74" name="BattBody 74"/>
+          <p:cNvSpPr/>
+          <p:nvPr/>
+        </p:nvSpPr>
+        <p:spPr>
+          <a:xfrm>
+            <a:off x="5719888" y="3610000"/>
+            <a:ext cx="720000" cy="380000"/>
+          </a:xfrm>
+          <a:prstGeom prst="roundRect">
+            <a:avLst>
+              <a:gd name="adj" fmla="val 15000"/>
+            </a:avLst>
+          </a:prstGeom>
+          <a:noFill/>
+          <a:ln w="28575">
+            <a:solidFill>
+              <a:srgbClr val="8B1A2B"/>
+            </a:solidFill>
+          </a:ln>
+        </p:spPr>
+        <p:txBody>
+          <a:bodyPr/>
+          <a:lstStyle/>
+          <a:p>
+            <a:endParaRPr lang="fr-FR"/>
+          </a:p>
+        </p:txBody>
+      </p:sp>
+      <p:sp>
+        <p:nvSpPr>
+          <p:cNvPr id="75" name="BattNub 75"/>
+          <p:cNvSpPr/>
+          <p:nvPr/>
+        </p:nvSpPr>
+        <p:spPr>
+          <a:xfrm>
+            <a:off x="6439888" y="3740000"/>
+            <a:ext cx="45000" cy="120000"/>
+          </a:xfrm>
+          <a:prstGeom prst="rect">
+            <a:avLst/>
+          </a:prstGeom>
+          <a:solidFill>
+            <a:srgbClr val="8B1A2B"/>
+          </a:solidFill>
+          <a:ln>
+            <a:noFill/>
+          </a:ln>
+        </p:spPr>
+        <p:txBody>
+          <a:bodyPr/>
+          <a:lstStyle/>
+          <a:p>
+            <a:endParaRPr lang="fr-FR"/>
+          </a:p>
+        </p:txBody>
+      </p:sp>
+      <p:sp>
+        <p:nvSpPr>
+          <p:cNvPr id="76" name="BattFill 76"/>
+          <p:cNvSpPr/>
+          <p:nvPr/>
+        </p:nvSpPr>
+        <p:spPr>
+          <a:xfrm>
+            <a:off x="5739888" y="3630000"/>
+            <a:ext cx="170000" cy="340000"/>
+          </a:xfrm>
+          <a:prstGeom prst="roundRect">
+            <a:avLst>
+              <a:gd name="adj" fmla="val 15000"/>
+            </a:avLst>
+          </a:prstGeom>
+          <a:solidFill>
+            <a:srgbClr val="C94F4F"/>
+          </a:solidFill>
+          <a:ln>
+            <a:noFill/>
+          </a:ln>
+        </p:spPr>
+        <p:txBody>
+          <a:bodyPr/>
+          <a:lstStyle/>
+          <a:p>
+            <a:endParaRPr lang="fr-FR"/>
+          </a:p>
+        </p:txBody>
+      </p:sp>
+      <p:sp>
+        <p:nvSpPr>
+          <p:cNvPr id="77" name="Text 77"/>
+          <p:cNvSpPr/>
+          <p:nvPr/>
+        </p:nvSpPr>
+        <p:spPr>
+          <a:xfrm>
+            <a:off x="5104888" y="4110000"/>
+            <a:ext cx="1950000" cy="700000"/>
+          </a:xfrm>
+          <a:prstGeom prst="rect">
+            <a:avLst/>
+          </a:prstGeom>
+          <a:noFill/>
+          <a:ln/>
+        </p:spPr>
+        <p:txBody>
+          <a:bodyPr wrap="square" lIns="0" tIns="0" rIns="0" bIns="0" rtlCol="0" anchor="t"/>
+          <a:lstStyle/>
+          <a:p>
+            <a:pPr marL="0" indent="0" algn="ctr">
+              <a:buNone/>
+            </a:pPr>
+            <a:r>
+              <a:rPr lang="fr-FR" sz="1500" b="1" dirty="0">
+                <a:solidFill>
+                  <a:srgbClr val="8B1A2B"/>
+                </a:solidFill>
+                <a:latin typeface="Poppins"/>
+              </a:rPr>
+              <a:t>Pile Rouge</a:t>
+            </a:r>
+          </a:p>
+          <a:p>
+            <a:pPr marL="0" indent="0" algn="ctr">
+              <a:buNone/>
+            </a:pPr>
+            <a:r>
+              <a:rPr lang="fr-FR" sz="1500" b="1" dirty="0">
+                <a:solidFill>
+                  <a:srgbClr val="8B1A2B"/>
+                </a:solidFill>
+                <a:latin typeface="Poppins"/>
+              </a:rPr>
+              <a:t>(Vide)</a:t>
+            </a:r>
+          </a:p>
+        </p:txBody>
+      </p:sp>
+      <p:sp>
+        <p:nvSpPr>
+          <p:cNvPr id="78" name="Text 78"/>
+          <p:cNvSpPr/>
+          <p:nvPr/>
+        </p:nvSpPr>
+        <p:spPr>
+          <a:xfrm>
+            <a:off x="5134888" y="4890000"/>
+            <a:ext cx="1890000" cy="2860000"/>
+          </a:xfrm>
+          <a:prstGeom prst="rect">
+            <a:avLst/>
+          </a:prstGeom>
+          <a:noFill/>
+          <a:ln/>
+        </p:spPr>
+        <p:txBody>
+          <a:bodyPr wrap="square" lIns="0" tIns="0" rIns="0" bIns="0" rtlCol="0" anchor="t"/>
+          <a:lstStyle/>
+          <a:p>
+            <a:pPr marL="0" indent="0" algn="ctr">
+              <a:buNone/>
+            </a:pPr>
+            <a:r>
+              <a:rPr lang="fr-FR" sz="1150" b="0" dirty="0">
+                <a:solidFill>
+                  <a:srgbClr val="333333"/>
+                </a:solidFill>
+                <a:latin typeface="Poppins"/>
+              </a:rPr>
+              <a:t>Batterie à plat ! Mes alarmes sonnent, j'ai besoin de me reposer pour recharger mon énergie.</a:t>
+            </a:r>
+          </a:p>
+        </p:txBody>
+      </p:sp>
+    </p:spTree>
+  </p:cSld>
+  <p:clrMapOvr>
+    <a:masterClrMapping/>
+  </p:clrMapOvr>
+</p:sld>
+</file>
+
+<file path=ppt/slides/slide11.xml><?xml version="1.0" encoding="utf-8"?>
+<p:sld xmlns:a="http://schemas.openxmlformats.org/drawingml/2006/main" xmlns:r="http://schemas.openxmlformats.org/officeDocument/2006/relationships" xmlns:p="http://schemas.openxmlformats.org/presentationml/2006/main">
+  <p:cSld name="Slide 2">
+    <p:bg>
+      <p:bgPr>
+        <a:blipFill dpi="0" rotWithShape="1">
+          <a:blip r:embed="rId3">
+            <a:lum/>
+          </a:blip>
+          <a:srcRect/>
+          <a:stretch>
+            <a:fillRect/>
+          </a:stretch>
+        </a:blipFill>
+        <a:effectLst/>
+      </p:bgPr>
+    </p:bg>
+    <p:spTree>
+      <p:nvGrpSpPr>
+        <p:cNvPr id="1" name=""/>
+        <p:cNvGrpSpPr/>
+        <p:nvPr/>
+      </p:nvGrpSpPr>
+      <p:grpSpPr>
+        <a:xfrm>
+          <a:off x="0" y="0"/>
+          <a:ext cx="0" cy="0"/>
+          <a:chOff x="0" y="0"/>
+          <a:chExt cx="0" cy="0"/>
+        </a:xfrm>
+      </p:grpSpPr>
+      <p:sp>
+        <p:nvSpPr>
+          <p:cNvPr id="2" name="Text 0"/>
+          <p:cNvSpPr/>
+          <p:nvPr/>
+        </p:nvSpPr>
+        <p:spPr>
+          <a:xfrm>
+            <a:off x="457200" y="365760"/>
+            <a:ext cx="6647688" cy="640080"/>
+          </a:xfrm>
+          <a:prstGeom prst="rect">
+            <a:avLst/>
+          </a:prstGeom>
+          <a:noFill/>
+          <a:ln/>
+        </p:spPr>
+        <p:txBody>
+          <a:bodyPr wrap="square" lIns="0" tIns="0" rIns="0" bIns="0" rtlCol="0" anchor="ctr"/>
+          <a:lstStyle/>
+          <a:p>
+            <a:pPr marL="0" indent="0" algn="ctr">
+              <a:buNone/>
+            </a:pPr>
+            <a:r>
+              <a:rPr lang="fr-FR" sz="2800" b="1" dirty="0">
+                <a:solidFill>
+                  <a:srgbClr val="8B1A2B"/>
+                </a:solidFill>
+                <a:latin typeface="Poppins" pitchFamily="34" charset="0"/>
+                <a:ea typeface="Calibri" pitchFamily="34" charset="-122"/>
+                <a:cs typeface="Calibri" pitchFamily="34" charset="-120"/>
+              </a:rPr>
+              <a:t>Mes équipements de Super-Héros !</a:t>
+            </a:r>
+            <a:endParaRPr lang="fr-FR" sz="2800" dirty="0"/>
+          </a:p>
+        </p:txBody>
+      </p:sp>
+      <p:sp>
+        <p:nvSpPr>
+          <p:cNvPr id="99" name="Footer"/>
+          <p:cNvSpPr/>
+          <p:nvPr/>
+        </p:nvSpPr>
+        <p:spPr>
+          <a:xfrm>
+            <a:off x="500000" y="10300000"/>
+            <a:ext cx="6562850" cy="300000"/>
+          </a:xfrm>
+          <a:prstGeom prst="rect">
+            <a:avLst/>
+          </a:prstGeom>
+          <a:noFill/>
+          <a:ln/>
+        </p:spPr>
+        <p:txBody>
+          <a:bodyPr wrap="square" lIns="0" tIns="0" rIns="0" bIns="0" rtlCol="0" anchor="ctr"/>
+          <a:lstStyle/>
+          <a:p>
+            <a:pPr marL="0" indent="0" algn="ctr">
+              <a:buNone/>
+            </a:pPr>
+            <a:r>
+              <a:rPr lang="fr-FR" sz="1000" i="1">
+                <a:solidFill>
+                  <a:srgbClr val="666666"/>
+                </a:solidFill>
+                <a:latin typeface="Poppins" pitchFamily="34" charset="0"/>
+                <a:ea typeface="Calibri" pitchFamily="34" charset="0"/>
+                <a:cs typeface="Calibri" pitchFamily="34" charset="0"/>
+              </a:rPr>
+              <a:t>Fait par l’association Sed’Occ France 04/2026</a:t>
+            </a:r>
+          </a:p>
+        </p:txBody>
+      </p:sp>
+      <p:pic>
+        <p:nvPicPr>
+          <p:cNvPr id="9" name="Image 8">
+            <a:extLst>
+              <a:ext uri="{FF2B5EF4-FFF2-40B4-BE49-F238E27FC236}">
+                <a16:creationId xmlns:a16="http://schemas.microsoft.com/office/drawing/2014/main" id="{1272B92B-21E4-464F-9F8E-4A62B1E16185}"/>
+              </a:ext>
+            </a:extLst>
+          </p:cNvPr>
+          <p:cNvPicPr>
+            <a:picLocks noChangeAspect="1"/>
+          </p:cNvPicPr>
+          <p:nvPr/>
+        </p:nvPicPr>
+        <p:blipFill rotWithShape="1">
+          <a:blip r:embed="rId5"/>
+          <a:srcRect l="9802" t="10888" r="15836" b="19876"/>
+          <a:stretch/>
+        </p:blipFill>
+        <p:spPr>
+          <a:xfrm>
+            <a:off x="6300000" y="9540000"/>
+            <a:ext cx="1080000" cy="1007999"/>
+          </a:xfrm>
+          <a:prstGeom prst="rect">
+            <a:avLst/>
+          </a:prstGeom>
+        </p:spPr>
+      </p:pic>
+      <p:sp>
+        <p:nvSpPr>
+          <p:cNvPr id="50" name="Text 50"/>
+          <p:cNvSpPr/>
+          <p:nvPr/>
+        </p:nvSpPr>
+        <p:spPr>
+          <a:xfrm>
+            <a:off x="457200" y="1080000"/>
+            <a:ext cx="6647688" cy="750000"/>
+          </a:xfrm>
+          <a:prstGeom prst="rect">
+            <a:avLst/>
+          </a:prstGeom>
+          <a:noFill/>
+          <a:ln/>
+        </p:spPr>
+        <p:txBody>
+          <a:bodyPr wrap="square" lIns="0" tIns="0" rIns="0" bIns="0" rtlCol="0" anchor="t"/>
+          <a:lstStyle/>
+          <a:p>
+            <a:pPr marL="0" indent="0" algn="ctr">
+              <a:buNone/>
+            </a:pPr>
+            <a:r>
+              <a:rPr lang="fr-FR" sz="2000" b="0" dirty="0">
+                <a:solidFill>
+                  <a:srgbClr val="333333"/>
+                </a:solidFill>
+                <a:latin typeface="Poppins"/>
+              </a:rPr>
+              <a:t>Pour aider notre colle spéciale, nous avons des supers outils. Ce sont des aides précieuses pour notre corps !</a:t>
+            </a:r>
+          </a:p>
+        </p:txBody>
+      </p:sp>
+      <p:pic>
+        <p:nvPicPr>
+          <p:cNvPr id="71" name="Equip 71"/>
+          <p:cNvPicPr>
+            <a:picLocks noChangeAspect="1"/>
+          </p:cNvPicPr>
+          <p:nvPr/>
+        </p:nvPicPr>
+        <p:blipFill>
+          <a:blip r:embed="rId7"/>
+          <a:stretch>
+            <a:fillRect/>
+          </a:stretch>
+        </p:blipFill>
+        <p:spPr>
+          <a:xfrm>
+            <a:off x="457200" y="2400000"/>
+            <a:ext cx="1050000" cy="1050000"/>
+          </a:xfrm>
+          <a:prstGeom prst="ellipse">
+            <a:avLst/>
+          </a:prstGeom>
+          <a:ln w="19050">
+            <a:solidFill>
+              <a:srgbClr val="8B1A2B">
+                <a:alpha val="30000"/>
+              </a:srgbClr>
+            </a:solidFill>
+          </a:ln>
+          <a:effectLst>
+            <a:outerShdw blurRad="50000" dist="20000" dir="5400000" algn="t" rotWithShape="0">
+              <a:srgbClr val="8B1A2B">
+                <a:alpha val="20000"/>
+              </a:srgbClr>
+            </a:outerShdw>
+          </a:effectLst>
+        </p:spPr>
+      </p:pic>
+      <p:sp>
+        <p:nvSpPr>
+          <p:cNvPr id="72" name="Text 72"/>
+          <p:cNvSpPr/>
+          <p:nvPr/>
+        </p:nvSpPr>
+        <p:spPr>
+          <a:xfrm>
+            <a:off x="1787200" y="2050000"/>
+            <a:ext cx="5317688" cy="1750000"/>
+          </a:xfrm>
+          <a:prstGeom prst="rect">
+            <a:avLst/>
+          </a:prstGeom>
+          <a:noFill/>
+          <a:ln/>
+        </p:spPr>
+        <p:txBody>
+          <a:bodyPr wrap="square" lIns="0" tIns="0" rIns="0" bIns="0" rtlCol="0" anchor="t"/>
+          <a:lstStyle/>
+          <a:p>
+            <a:pPr marL="0" indent="0" algn="l">
+              <a:buNone/>
+            </a:pPr>
+            <a:r>
+              <a:rPr lang="fr-FR" sz="1900" b="1" dirty="0">
+                <a:solidFill>
+                  <a:srgbClr val="8B1A2B"/>
+                </a:solidFill>
+                <a:latin typeface="Poppins"/>
+              </a:rPr>
+              <a:t>Les Boucliers Magiques </a:t>
+            </a:r>
+            <a:r>
+              <a:rPr lang="fr-FR" sz="1900" b="0" dirty="0">
+                <a:solidFill>
+                  <a:srgbClr val="8B1A2B"/>
+                </a:solidFill>
+                <a:latin typeface="Poppins"/>
+              </a:rPr>
+              <a:t>(les attelles)</a:t>
+            </a:r>
+          </a:p>
+        </p:txBody>
+      </p:sp>
+      <p:sp>
+        <p:nvSpPr>
+          <p:cNvPr id="73" name="Text 73"/>
+          <p:cNvSpPr/>
+          <p:nvPr/>
+        </p:nvSpPr>
+        <p:spPr>
+          <a:xfrm>
+            <a:off x="1787200" y="2600000"/>
+            <a:ext cx="5317688" cy="1200000"/>
+          </a:xfrm>
+          <a:prstGeom prst="rect">
+            <a:avLst/>
+          </a:prstGeom>
+          <a:noFill/>
+          <a:ln/>
+        </p:spPr>
+        <p:txBody>
+          <a:bodyPr wrap="square" lIns="0" tIns="0" rIns="0" bIns="0" rtlCol="0" anchor="t"/>
+          <a:lstStyle/>
+          <a:p>
+            <a:pPr marL="0" indent="0" algn="l">
+              <a:buNone/>
+            </a:pPr>
+            <a:r>
+              <a:rPr lang="fr-FR" sz="1500" b="0" dirty="0">
+                <a:solidFill>
+                  <a:srgbClr val="333333"/>
+                </a:solidFill>
+                <a:latin typeface="Poppins"/>
+              </a:rPr>
+              <a:t>Ils protègent les articulations pour qu'elles restent bien en place et ne fassent pas de bêtises.</a:t>
+            </a:r>
+          </a:p>
+        </p:txBody>
+      </p:sp>
+      <p:pic>
+        <p:nvPicPr>
+          <p:cNvPr id="74" name="Equip 74"/>
+          <p:cNvPicPr>
+            <a:picLocks noChangeAspect="1"/>
+          </p:cNvPicPr>
+          <p:nvPr/>
+        </p:nvPicPr>
+        <p:blipFill>
+          <a:blip r:embed="rId8"/>
+          <a:stretch>
+            <a:fillRect/>
+          </a:stretch>
+        </p:blipFill>
+        <p:spPr>
+          <a:xfrm>
+            <a:off x="457200" y="4370000"/>
+            <a:ext cx="1050000" cy="1050000"/>
+          </a:xfrm>
+          <a:prstGeom prst="ellipse">
+            <a:avLst/>
+          </a:prstGeom>
+          <a:ln w="19050">
+            <a:solidFill>
+              <a:srgbClr val="8B1A2B">
+                <a:alpha val="30000"/>
+              </a:srgbClr>
+            </a:solidFill>
+          </a:ln>
+          <a:effectLst>
+            <a:outerShdw blurRad="50000" dist="20000" dir="5400000" algn="t" rotWithShape="0">
+              <a:srgbClr val="8B1A2B">
+                <a:alpha val="20000"/>
+              </a:srgbClr>
+            </a:outerShdw>
+          </a:effectLst>
+        </p:spPr>
+      </p:pic>
+      <p:sp>
+        <p:nvSpPr>
+          <p:cNvPr id="75" name="Text 75"/>
+          <p:cNvSpPr/>
+          <p:nvPr/>
+        </p:nvSpPr>
+        <p:spPr>
+          <a:xfrm>
+            <a:off x="1787200" y="4020000"/>
+            <a:ext cx="5317688" cy="1750000"/>
+          </a:xfrm>
+          <a:prstGeom prst="rect">
+            <a:avLst/>
+          </a:prstGeom>
+          <a:noFill/>
+          <a:ln/>
+        </p:spPr>
+        <p:txBody>
+          <a:bodyPr wrap="square" lIns="0" tIns="0" rIns="0" bIns="0" rtlCol="0" anchor="t"/>
+          <a:lstStyle/>
+          <a:p>
+            <a:pPr marL="0" indent="0" algn="l">
+              <a:buNone/>
+            </a:pPr>
+            <a:r>
+              <a:rPr lang="fr-FR" sz="1900" b="1" dirty="0">
+                <a:solidFill>
+                  <a:srgbClr val="8B1A2B"/>
+                </a:solidFill>
+                <a:latin typeface="Poppins"/>
+              </a:rPr>
+              <a:t>L'Armure Secrète </a:t>
+            </a:r>
+            <a:r>
+              <a:rPr lang="fr-FR" sz="1900" b="0" dirty="0">
+                <a:solidFill>
+                  <a:srgbClr val="8B1A2B"/>
+                </a:solidFill>
+                <a:latin typeface="Poppins"/>
+              </a:rPr>
+              <a:t>(les vêtements de compression)</a:t>
+            </a:r>
+          </a:p>
+        </p:txBody>
+      </p:sp>
+      <p:sp>
+        <p:nvSpPr>
+          <p:cNvPr id="76" name="Text 76"/>
+          <p:cNvSpPr/>
+          <p:nvPr/>
+        </p:nvSpPr>
+        <p:spPr>
+          <a:xfrm>
+            <a:off x="1787200" y="4570000"/>
+            <a:ext cx="5317688" cy="1200000"/>
+          </a:xfrm>
+          <a:prstGeom prst="rect">
+            <a:avLst/>
+          </a:prstGeom>
+          <a:noFill/>
+          <a:ln/>
+        </p:spPr>
+        <p:txBody>
+          <a:bodyPr wrap="square" lIns="0" tIns="0" rIns="0" bIns="0" rtlCol="0" anchor="t"/>
+          <a:lstStyle/>
+          <a:p>
+            <a:pPr marL="0" indent="0" algn="l">
+              <a:buNone/>
+            </a:pPr>
+            <a:r>
+              <a:rPr lang="fr-FR" sz="1500" b="0" dirty="0">
+                <a:solidFill>
+                  <a:srgbClr val="333333"/>
+                </a:solidFill>
+                <a:latin typeface="Poppins"/>
+              </a:rPr>
+              <a:t>Elle serre un petit peu, comme un gros câlin, pour aider le corps à se tenir bien droit et à moins se fatiguer.</a:t>
+            </a:r>
+          </a:p>
+        </p:txBody>
+      </p:sp>
+      <p:pic>
+        <p:nvPicPr>
+          <p:cNvPr id="77" name="Equip 77"/>
+          <p:cNvPicPr>
+            <a:picLocks noChangeAspect="1"/>
+          </p:cNvPicPr>
+          <p:nvPr/>
+        </p:nvPicPr>
+        <p:blipFill>
+          <a:blip r:embed="rId9"/>
+          <a:stretch>
+            <a:fillRect/>
+          </a:stretch>
+        </p:blipFill>
+        <p:spPr>
+          <a:xfrm>
+            <a:off x="457200" y="6340000"/>
+            <a:ext cx="1050000" cy="1050000"/>
+          </a:xfrm>
+          <a:prstGeom prst="ellipse">
+            <a:avLst/>
+          </a:prstGeom>
+          <a:ln w="19050">
+            <a:solidFill>
+              <a:srgbClr val="8B1A2B">
+                <a:alpha val="30000"/>
+              </a:srgbClr>
+            </a:solidFill>
+          </a:ln>
+          <a:effectLst>
+            <a:outerShdw blurRad="50000" dist="20000" dir="5400000" algn="t" rotWithShape="0">
+              <a:srgbClr val="8B1A2B">
+                <a:alpha val="20000"/>
+              </a:srgbClr>
+            </a:outerShdw>
+          </a:effectLst>
+        </p:spPr>
+      </p:pic>
+      <p:sp>
+        <p:nvSpPr>
+          <p:cNvPr id="78" name="Text 78"/>
+          <p:cNvSpPr/>
+          <p:nvPr/>
+        </p:nvSpPr>
+        <p:spPr>
+          <a:xfrm>
+            <a:off x="1787200" y="5990000"/>
+            <a:ext cx="5317688" cy="1750000"/>
+          </a:xfrm>
+          <a:prstGeom prst="rect">
+            <a:avLst/>
+          </a:prstGeom>
+          <a:noFill/>
+          <a:ln/>
+        </p:spPr>
+        <p:txBody>
+          <a:bodyPr wrap="square" lIns="0" tIns="0" rIns="0" bIns="0" rtlCol="0" anchor="t"/>
+          <a:lstStyle/>
+          <a:p>
+            <a:pPr marL="0" indent="0" algn="l">
+              <a:buNone/>
+            </a:pPr>
+            <a:r>
+              <a:rPr lang="fr-FR" sz="1900" b="1" dirty="0">
+                <a:solidFill>
+                  <a:srgbClr val="8B1A2B"/>
+                </a:solidFill>
+                <a:latin typeface="Poppins"/>
+              </a:rPr>
+              <a:t>Les Super-Propulseurs </a:t>
+            </a:r>
+            <a:r>
+              <a:rPr lang="fr-FR" sz="1900" b="0" dirty="0">
+                <a:solidFill>
+                  <a:srgbClr val="8B1A2B"/>
+                </a:solidFill>
+                <a:latin typeface="Poppins"/>
+              </a:rPr>
+              <a:t>(les béquilles ou le fauteuil)</a:t>
+            </a:r>
+          </a:p>
+        </p:txBody>
+      </p:sp>
+      <p:sp>
+        <p:nvSpPr>
+          <p:cNvPr id="79" name="Text 79"/>
+          <p:cNvSpPr/>
+          <p:nvPr/>
+        </p:nvSpPr>
+        <p:spPr>
+          <a:xfrm>
+            <a:off x="1787200" y="6540000"/>
+            <a:ext cx="5317688" cy="1200000"/>
+          </a:xfrm>
+          <a:prstGeom prst="rect">
+            <a:avLst/>
+          </a:prstGeom>
+          <a:noFill/>
+          <a:ln/>
+        </p:spPr>
+        <p:txBody>
+          <a:bodyPr wrap="square" lIns="0" tIns="0" rIns="0" bIns="0" rtlCol="0" anchor="t"/>
+          <a:lstStyle/>
+          <a:p>
+            <a:pPr marL="0" indent="0" algn="l">
+              <a:buNone/>
+            </a:pPr>
+            <a:r>
+              <a:rPr lang="fr-FR" sz="1500" b="0" dirty="0">
+                <a:solidFill>
+                  <a:srgbClr val="333333"/>
+                </a:solidFill>
+                <a:latin typeface="Poppins"/>
+              </a:rPr>
+              <a:t>Quand les jambes n'ont plus de batterie, ils nous aident à avancer et à nous reposer en même temps !</a:t>
+            </a:r>
+          </a:p>
+        </p:txBody>
+      </p:sp>
+    </p:spTree>
+  </p:cSld>
+  <p:clrMapOvr>
+    <a:masterClrMapping/>
+  </p:clrMapOvr>
+</p:sld>
+</file>
+
+<file path=ppt/slides/slide12.xml><?xml version="1.0" encoding="utf-8"?>
+<p:sld xmlns:a="http://schemas.openxmlformats.org/drawingml/2006/main" xmlns:r="http://schemas.openxmlformats.org/officeDocument/2006/relationships" xmlns:p="http://schemas.openxmlformats.org/presentationml/2006/main">
+  <p:cSld name="Slide 2">
+    <p:bg>
+      <p:bgPr>
+        <a:blipFill dpi="0" rotWithShape="1">
+          <a:blip r:embed="rId3">
+            <a:lum/>
+          </a:blip>
+          <a:srcRect/>
+          <a:stretch>
+            <a:fillRect/>
+          </a:stretch>
+        </a:blipFill>
+        <a:effectLst/>
+      </p:bgPr>
+    </p:bg>
+    <p:spTree>
+      <p:nvGrpSpPr>
+        <p:cNvPr id="1" name=""/>
+        <p:cNvGrpSpPr/>
+        <p:nvPr/>
+      </p:nvGrpSpPr>
+      <p:grpSpPr>
+        <a:xfrm>
+          <a:off x="0" y="0"/>
+          <a:ext cx="0" cy="0"/>
+          <a:chOff x="0" y="0"/>
+          <a:chExt cx="0" cy="0"/>
+        </a:xfrm>
+      </p:grpSpPr>
+      <p:sp>
+        <p:nvSpPr>
+          <p:cNvPr id="2" name="Text 0"/>
+          <p:cNvSpPr/>
+          <p:nvPr/>
+        </p:nvSpPr>
+        <p:spPr>
+          <a:xfrm>
+            <a:off x="457200" y="365760"/>
+            <a:ext cx="6647688" cy="640080"/>
+          </a:xfrm>
+          <a:prstGeom prst="rect">
+            <a:avLst/>
+          </a:prstGeom>
+          <a:noFill/>
+          <a:ln/>
+        </p:spPr>
+        <p:txBody>
+          <a:bodyPr wrap="square" lIns="0" tIns="0" rIns="0" bIns="0" rtlCol="0" anchor="ctr"/>
+          <a:lstStyle/>
+          <a:p>
+            <a:pPr marL="0" indent="0" algn="ctr">
+              <a:buNone/>
+            </a:pPr>
+            <a:r>
+              <a:rPr lang="fr-FR" sz="2800" b="1" dirty="0">
+                <a:solidFill>
+                  <a:srgbClr val="8B1A2B"/>
+                </a:solidFill>
+                <a:latin typeface="Poppins" pitchFamily="34" charset="0"/>
+                <a:ea typeface="Calibri" pitchFamily="34" charset="-122"/>
+                <a:cs typeface="Calibri" pitchFamily="34" charset="-120"/>
+              </a:rPr>
+              <a:t>Le Pacte des Supers Copains !</a:t>
+            </a:r>
+            <a:endParaRPr lang="fr-FR" sz="2800" dirty="0"/>
+          </a:p>
+        </p:txBody>
+      </p:sp>
+      <p:sp>
+        <p:nvSpPr>
+          <p:cNvPr id="99" name="Footer"/>
+          <p:cNvSpPr/>
+          <p:nvPr/>
+        </p:nvSpPr>
+        <p:spPr>
+          <a:xfrm>
+            <a:off x="500000" y="10300000"/>
+            <a:ext cx="6562850" cy="300000"/>
+          </a:xfrm>
+          <a:prstGeom prst="rect">
+            <a:avLst/>
+          </a:prstGeom>
+          <a:noFill/>
+          <a:ln/>
+        </p:spPr>
+        <p:txBody>
+          <a:bodyPr wrap="square" lIns="0" tIns="0" rIns="0" bIns="0" rtlCol="0" anchor="ctr"/>
+          <a:lstStyle/>
+          <a:p>
+            <a:pPr marL="0" indent="0" algn="ctr">
+              <a:buNone/>
+            </a:pPr>
+            <a:r>
+              <a:rPr lang="fr-FR" sz="1000" i="1">
+                <a:solidFill>
+                  <a:srgbClr val="666666"/>
+                </a:solidFill>
+                <a:latin typeface="Poppins" pitchFamily="34" charset="0"/>
+                <a:ea typeface="Calibri" pitchFamily="34" charset="0"/>
+                <a:cs typeface="Calibri" pitchFamily="34" charset="0"/>
+              </a:rPr>
+              <a:t>Fait par l’association Sed’Occ France 04/2026</a:t>
+            </a:r>
+          </a:p>
+        </p:txBody>
+      </p:sp>
+      <p:pic>
+        <p:nvPicPr>
+          <p:cNvPr id="9" name="Image 8">
+            <a:extLst>
+              <a:ext uri="{FF2B5EF4-FFF2-40B4-BE49-F238E27FC236}">
+                <a16:creationId xmlns:a16="http://schemas.microsoft.com/office/drawing/2014/main" id="{1272B92B-21E4-464F-9F8E-4A62B1E16185}"/>
+              </a:ext>
+            </a:extLst>
+          </p:cNvPr>
+          <p:cNvPicPr>
+            <a:picLocks noChangeAspect="1"/>
+          </p:cNvPicPr>
+          <p:nvPr/>
+        </p:nvPicPr>
+        <p:blipFill rotWithShape="1">
+          <a:blip r:embed="rId5"/>
+          <a:srcRect l="9802" t="10888" r="15836" b="19876"/>
+          <a:stretch/>
+        </p:blipFill>
+        <p:spPr>
+          <a:xfrm>
+            <a:off x="6300000" y="9540000"/>
+            <a:ext cx="1080000" cy="1007999"/>
+          </a:xfrm>
+          <a:prstGeom prst="rect">
+            <a:avLst/>
+          </a:prstGeom>
+        </p:spPr>
+      </p:pic>
+      <p:sp>
+        <p:nvSpPr>
+          <p:cNvPr id="50" name="Text 50"/>
+          <p:cNvSpPr/>
+          <p:nvPr/>
+        </p:nvSpPr>
+        <p:spPr>
+          <a:xfrm>
+            <a:off x="457200" y="1080000"/>
+            <a:ext cx="6647688" cy="1300000"/>
+          </a:xfrm>
+          <a:prstGeom prst="rect">
+            <a:avLst/>
+          </a:prstGeom>
+          <a:noFill/>
+          <a:ln/>
+        </p:spPr>
+        <p:txBody>
+          <a:bodyPr wrap="square" lIns="0" tIns="0" rIns="0" bIns="0" rtlCol="0" anchor="t"/>
+          <a:lstStyle/>
+          <a:p>
+            <a:pPr marL="0" indent="0" algn="ctr">
+              <a:buNone/>
+            </a:pPr>
+            <a:r>
+              <a:rPr lang="fr-FR" sz="1800" b="0" dirty="0">
+                <a:solidFill>
+                  <a:srgbClr val="333333"/>
+                </a:solidFill>
+                <a:latin typeface="Poppins"/>
+              </a:rPr>
+              <a:t>Ton copain avec le SED a une colle spéciale qui le rend plus fragile. Ce n'est pas de sa faute, et il a besoin de ta gentillesse ! Pas besoin de se pousser pour bien rigoler !</a:t>
+            </a:r>
+          </a:p>
+        </p:txBody>
+      </p:sp>
+      <p:sp>
+        <p:nvSpPr>
+          <p:cNvPr id="51" name="DiplomaBox"/>
+          <p:cNvSpPr/>
+          <p:nvPr/>
+        </p:nvSpPr>
+        <p:spPr>
+          <a:xfrm>
+            <a:off x="650000" y="2550000"/>
+            <a:ext cx="6262850" cy="7250000"/>
+          </a:xfrm>
+          <a:prstGeom prst="roundRect">
+            <a:avLst>
+              <a:gd name="adj" fmla="val 3500"/>
+            </a:avLst>
+          </a:prstGeom>
+          <a:solidFill>
+            <a:srgbClr val="FFFFFF"/>
+          </a:solidFill>
+          <a:ln w="34925" cmpd="dbl">
+            <a:solidFill>
+              <a:srgbClr val="8B1A2B"/>
+            </a:solidFill>
+          </a:ln>
+        </p:spPr>
+        <p:txBody>
+          <a:bodyPr/>
+          <a:lstStyle/>
+          <a:p>
+            <a:endParaRPr lang="fr-FR"/>
+          </a:p>
+        </p:txBody>
+      </p:sp>
+      <p:pic>
+        <p:nvPicPr>
+          <p:cNvPr id="52" name="Badge"/>
+          <p:cNvPicPr>
+            <a:picLocks noChangeAspect="1"/>
+          </p:cNvPicPr>
+          <p:nvPr/>
+        </p:nvPicPr>
+        <p:blipFill>
+          <a:blip r:embed="rId4"/>
+          <a:stretch>
+            <a:fillRect/>
+          </a:stretch>
+        </p:blipFill>
+        <p:spPr>
+          <a:xfrm>
+            <a:off x="3331425" y="2850000"/>
+            <a:ext cx="900000" cy="900000"/>
+          </a:xfrm>
+          <a:prstGeom prst="rect">
+            <a:avLst/>
+          </a:prstGeom>
+        </p:spPr>
+      </p:pic>
+      <p:sp>
+        <p:nvSpPr>
+          <p:cNvPr id="53" name="Text 53"/>
+          <p:cNvSpPr/>
+          <p:nvPr/>
+        </p:nvSpPr>
+        <p:spPr>
+          <a:xfrm>
+            <a:off x="950000" y="3970000"/>
+            <a:ext cx="5662850" cy="500000"/>
+          </a:xfrm>
+          <a:prstGeom prst="rect">
+            <a:avLst/>
+          </a:prstGeom>
+          <a:noFill/>
+          <a:ln/>
+        </p:spPr>
+        <p:txBody>
+          <a:bodyPr wrap="square" lIns="0" tIns="0" rIns="0" bIns="0" rtlCol="0" anchor="t"/>
+          <a:lstStyle/>
+          <a:p>
+            <a:pPr marL="0" indent="0" algn="ctr">
+              <a:buNone/>
+            </a:pPr>
+            <a:r>
+              <a:rPr lang="fr-FR" sz="1800" b="1" dirty="0">
+                <a:solidFill>
+                  <a:srgbClr val="8B1A2B"/>
+                </a:solidFill>
+                <a:latin typeface="Poppins"/>
+              </a:rPr>
+              <a:t>En signant ce diplôme de Super Copain, je m'engage à :</a:t>
+            </a:r>
+          </a:p>
+        </p:txBody>
+      </p:sp>
+      <p:sp>
+        <p:nvSpPr>
+          <p:cNvPr id="54" name="Bullets 54"/>
+          <p:cNvSpPr/>
+          <p:nvPr/>
+        </p:nvSpPr>
+        <p:spPr>
+          <a:xfrm>
+            <a:off x="1200000" y="4570000"/>
+            <a:ext cx="5162850" cy="3200000"/>
+          </a:xfrm>
+          <a:prstGeom prst="rect">
+            <a:avLst/>
+          </a:prstGeom>
+          <a:noFill/>
+          <a:ln/>
+        </p:spPr>
+        <p:txBody>
+          <a:bodyPr wrap="square" lIns="0" tIns="0" rIns="0" bIns="0" rtlCol="0" anchor="t"/>
+          <a:lstStyle/>
+          <a:p>
+            <a:pPr marL="342900" indent="-342900">
+              <a:buFont typeface="Arial"/>
+              <a:buChar char="•"/>
+            </a:pPr>
+            <a:r>
+              <a:rPr lang="fr-FR" sz="1700" dirty="0">
+                <a:solidFill>
+                  <a:srgbClr val="333333"/>
+                </a:solidFill>
+                <a:latin typeface="Poppins"/>
+              </a:rPr>
+              <a:t>Écouter mon copain s'il me dit que sa batterie est à plat.</a:t>
+            </a:r>
+          </a:p>
+          <a:p>
+            <a:pPr marL="342900" indent="-342900">
+              <a:buFont typeface="Arial"/>
+              <a:buChar char="•"/>
+            </a:pPr>
+            <a:r>
+              <a:rPr lang="fr-FR" sz="1700" dirty="0">
+                <a:solidFill>
+                  <a:srgbClr val="333333"/>
+                </a:solidFill>
+                <a:latin typeface="Poppins"/>
+              </a:rPr>
+              <a:t>Choisir des jeux sans bousculade ensemble avec lui (comme la marelle, les jeux de société, inventer des histoires...).</a:t>
+            </a:r>
+          </a:p>
+          <a:p>
+            <a:pPr marL="342900" indent="-342900">
+              <a:buFont typeface="Arial"/>
+              <a:buChar char="•"/>
+            </a:pPr>
+            <a:r>
+              <a:rPr lang="fr-FR" sz="1700" dirty="0">
+                <a:solidFill>
+                  <a:srgbClr val="333333"/>
+                </a:solidFill>
+                <a:latin typeface="Poppins"/>
+              </a:rPr>
+              <a:t>Me rappeler que même si sa colle est différente, ensemble, on est plus forts !</a:t>
+            </a:r>
+          </a:p>
+        </p:txBody>
+      </p:sp>
+      <p:sp>
+        <p:nvSpPr>
+          <p:cNvPr id="55" name="Text 55"/>
+          <p:cNvSpPr/>
+          <p:nvPr/>
+        </p:nvSpPr>
+        <p:spPr>
+          <a:xfrm>
+            <a:off x="950000" y="8700000"/>
+            <a:ext cx="5662850" cy="700000"/>
+          </a:xfrm>
+          <a:prstGeom prst="rect">
+            <a:avLst/>
+          </a:prstGeom>
+          <a:noFill/>
+          <a:ln/>
+        </p:spPr>
+        <p:txBody>
+          <a:bodyPr wrap="square" lIns="0" tIns="0" rIns="0" bIns="0" rtlCol="0" anchor="t"/>
+          <a:lstStyle/>
+          <a:p>
+            <a:pPr marL="0" indent="0" algn="ctr">
+              <a:buNone/>
+            </a:pPr>
+            <a:r>
+              <a:rPr lang="fr-FR" sz="1700" b="1" dirty="0">
+                <a:solidFill>
+                  <a:srgbClr val="8B1A2B"/>
+                </a:solidFill>
+                <a:latin typeface="Poppins"/>
+              </a:rPr>
+              <a:t>Signature du super copain : _________________________</a:t>
+            </a:r>
+          </a:p>
+        </p:txBody>
+      </p:sp>
+    </p:spTree>
+  </p:cSld>
+  <p:clrMapOvr>
+    <a:masterClrMapping/>
+  </p:clrMapOvr>
+</p:sld>
+</file>
+
+<file path=ppt/slides/slide13.xml><?xml version="1.0" encoding="utf-8"?>
+<p:sld xmlns:a="http://schemas.openxmlformats.org/drawingml/2006/main" xmlns:r="http://schemas.openxmlformats.org/officeDocument/2006/relationships" xmlns:p="http://schemas.openxmlformats.org/presentationml/2006/main">
+  <p:cSld name="Slide 2">
+    <p:bg>
+      <p:bgPr>
+        <a:blipFill dpi="0" rotWithShape="1">
+          <a:blip r:embed="rId3">
+            <a:lum/>
+          </a:blip>
+          <a:srcRect/>
+          <a:stretch>
+            <a:fillRect/>
+          </a:stretch>
+        </a:blipFill>
+        <a:effectLst/>
+      </p:bgPr>
+    </p:bg>
+    <p:spTree>
+      <p:nvGrpSpPr>
+        <p:cNvPr id="1" name=""/>
+        <p:cNvGrpSpPr/>
+        <p:nvPr/>
+      </p:nvGrpSpPr>
+      <p:grpSpPr>
+        <a:xfrm>
+          <a:off x="0" y="0"/>
+          <a:ext cx="0" cy="0"/>
+          <a:chOff x="0" y="0"/>
+          <a:chExt cx="0" cy="0"/>
+        </a:xfrm>
+      </p:grpSpPr>
+      <p:sp>
+        <p:nvSpPr>
+          <p:cNvPr id="2" name="Text 0"/>
+          <p:cNvSpPr/>
+          <p:nvPr/>
+        </p:nvSpPr>
+        <p:spPr>
+          <a:xfrm>
+            <a:off x="457200" y="365760"/>
+            <a:ext cx="6647688" cy="640080"/>
+          </a:xfrm>
+          <a:prstGeom prst="rect">
+            <a:avLst/>
+          </a:prstGeom>
+          <a:noFill/>
+          <a:ln/>
+        </p:spPr>
+        <p:txBody>
+          <a:bodyPr wrap="square" lIns="0" tIns="0" rIns="0" bIns="0" rtlCol="0" anchor="ctr"/>
+          <a:lstStyle/>
+          <a:p>
+            <a:pPr marL="0" indent="0" algn="ctr">
+              <a:buNone/>
+            </a:pPr>
+            <a:r>
+              <a:rPr lang="fr-FR" sz="2800" b="1" dirty="0">
+                <a:solidFill>
+                  <a:srgbClr val="8B1A2B"/>
+                </a:solidFill>
+                <a:latin typeface="Poppins" pitchFamily="34" charset="0"/>
+                <a:ea typeface="Calibri" pitchFamily="34" charset="-122"/>
+                <a:cs typeface="Calibri" pitchFamily="34" charset="-120"/>
+              </a:rPr>
+              <a:t>À toi de créer ton propre Super-Héros !</a:t>
+            </a:r>
+            <a:endParaRPr lang="fr-FR" sz="2800" dirty="0"/>
+          </a:p>
+        </p:txBody>
+      </p:sp>
+      <p:sp>
+        <p:nvSpPr>
+          <p:cNvPr id="99" name="Footer"/>
+          <p:cNvSpPr/>
+          <p:nvPr/>
+        </p:nvSpPr>
+        <p:spPr>
+          <a:xfrm>
+            <a:off x="500000" y="10300000"/>
+            <a:ext cx="6562850" cy="300000"/>
+          </a:xfrm>
+          <a:prstGeom prst="rect">
+            <a:avLst/>
+          </a:prstGeom>
+          <a:noFill/>
+          <a:ln/>
+        </p:spPr>
+        <p:txBody>
+          <a:bodyPr wrap="square" lIns="0" tIns="0" rIns="0" bIns="0" rtlCol="0" anchor="ctr"/>
+          <a:lstStyle/>
+          <a:p>
+            <a:pPr marL="0" indent="0" algn="ctr">
+              <a:buNone/>
+            </a:pPr>
+            <a:r>
+              <a:rPr lang="fr-FR" sz="1000" i="1">
+                <a:solidFill>
+                  <a:srgbClr val="666666"/>
+                </a:solidFill>
+                <a:latin typeface="Poppins" pitchFamily="34" charset="0"/>
+                <a:ea typeface="Calibri" pitchFamily="34" charset="0"/>
+                <a:cs typeface="Calibri" pitchFamily="34" charset="0"/>
+              </a:rPr>
+              <a:t>Fait par l’association Sed’Occ France 04/2026</a:t>
+            </a:r>
+          </a:p>
+        </p:txBody>
+      </p:sp>
+      <p:pic>
+        <p:nvPicPr>
+          <p:cNvPr id="9" name="Image 8">
+            <a:extLst>
+              <a:ext uri="{FF2B5EF4-FFF2-40B4-BE49-F238E27FC236}">
+                <a16:creationId xmlns:a16="http://schemas.microsoft.com/office/drawing/2014/main" id="{1272B92B-21E4-464F-9F8E-4A62B1E16185}"/>
+              </a:ext>
+            </a:extLst>
+          </p:cNvPr>
+          <p:cNvPicPr>
+            <a:picLocks noChangeAspect="1"/>
+          </p:cNvPicPr>
+          <p:nvPr/>
+        </p:nvPicPr>
+        <p:blipFill rotWithShape="1">
+          <a:blip r:embed="rId5"/>
+          <a:srcRect l="9802" t="10888" r="15836" b="19876"/>
+          <a:stretch/>
+        </p:blipFill>
+        <p:spPr>
+          <a:xfrm>
+            <a:off x="6300000" y="9540000"/>
+            <a:ext cx="1080000" cy="1007999"/>
+          </a:xfrm>
+          <a:prstGeom prst="rect">
+            <a:avLst/>
+          </a:prstGeom>
+        </p:spPr>
+      </p:pic>
+      <p:sp>
+        <p:nvSpPr>
+          <p:cNvPr id="50" name="Text 50"/>
+          <p:cNvSpPr/>
+          <p:nvPr/>
+        </p:nvSpPr>
+        <p:spPr>
+          <a:xfrm>
+            <a:off x="457200" y="1080000"/>
+            <a:ext cx="6647688" cy="1650000"/>
+          </a:xfrm>
+          <a:prstGeom prst="rect">
+            <a:avLst/>
+          </a:prstGeom>
+          <a:noFill/>
+          <a:ln/>
+        </p:spPr>
+        <p:txBody>
+          <a:bodyPr wrap="square" lIns="0" tIns="0" rIns="0" bIns="0" rtlCol="0" anchor="t"/>
+          <a:lstStyle/>
+          <a:p>
+            <a:pPr marL="0" indent="0" algn="ctr">
+              <a:buNone/>
+            </a:pPr>
+            <a:r>
+              <a:rPr lang="fr-FR" sz="1700" b="0" dirty="0">
+                <a:solidFill>
+                  <a:srgbClr val="333333"/>
+                </a:solidFill>
+                <a:latin typeface="Poppins"/>
+              </a:rPr>
+              <a:t>Tu as découvert le secret de la colle magique et tu as appris à écouter ta grande batterie. Tu sais quoi ? Gérer tout ça tous les jours fait de toi un vrai super-héros !</a:t>
+            </a:r>
+          </a:p>
+        </p:txBody>
+      </p:sp>
+      <p:sp>
+        <p:nvSpPr>
+          <p:cNvPr id="51" name="Text 51"/>
+          <p:cNvSpPr/>
+          <p:nvPr/>
+        </p:nvSpPr>
+        <p:spPr>
+          <a:xfrm>
+            <a:off x="457200" y="2750000"/>
+            <a:ext cx="6647688" cy="1100000"/>
+          </a:xfrm>
+          <a:prstGeom prst="rect">
+            <a:avLst/>
+          </a:prstGeom>
+          <a:noFill/>
+          <a:ln/>
+        </p:spPr>
+        <p:txBody>
+          <a:bodyPr wrap="square" lIns="0" tIns="0" rIns="0" bIns="0" rtlCol="0" anchor="t"/>
+          <a:lstStyle/>
+          <a:p>
+            <a:pPr marL="0" indent="0" algn="ctr">
+              <a:buNone/>
+            </a:pPr>
+            <a:r>
+              <a:rPr lang="fr-FR" sz="1600" b="0" dirty="0">
+                <a:solidFill>
+                  <a:srgbClr val="333333"/>
+                </a:solidFill>
+                <a:latin typeface="Poppins"/>
+              </a:rPr>
+              <a:t>À quoi ressemble ton costume ? Dessine-toi en super-héros ou colorie la silhouette ci-dessous. N'oublie pas de choisir tes couleurs préférées et de rajouter tes supers outils pour t'aider !</a:t>
+            </a:r>
+          </a:p>
+        </p:txBody>
+      </p:sp>
+      <p:sp>
+        <p:nvSpPr>
+          <p:cNvPr id="60" name="DrawBox"/>
+          <p:cNvSpPr/>
+          <p:nvPr/>
+        </p:nvSpPr>
+        <p:spPr>
+          <a:xfrm>
+            <a:off x="1781425" y="4050000"/>
+            <a:ext cx="4000000" cy="5450000"/>
+          </a:xfrm>
+          <a:prstGeom prst="roundRect">
+            <a:avLst>
+              <a:gd name="adj" fmla="val 4000"/>
+            </a:avLst>
+          </a:prstGeom>
+          <a:solidFill>
+            <a:srgbClr val="FFFFFF"/>
+          </a:solidFill>
+          <a:ln w="28575">
+            <a:solidFill>
+              <a:srgbClr val="E8963D"/>
+            </a:solidFill>
+            <a:prstDash val="dash"/>
+          </a:ln>
+        </p:spPr>
+        <p:txBody>
+          <a:bodyPr/>
+          <a:lstStyle/>
+          <a:p>
+            <a:endParaRPr lang="fr-FR"/>
+          </a:p>
+        </p:txBody>
+      </p:sp>
+      <p:sp>
+        <p:nvSpPr>
+          <p:cNvPr id="61" name="Sil61"/>
+          <p:cNvSpPr/>
+          <p:nvPr/>
+        </p:nvSpPr>
+        <p:spPr>
+          <a:xfrm>
+            <a:off x="2959717" y="5624940"/>
+            <a:ext cx="1643256" cy="2011572"/>
+          </a:xfrm>
+          <a:prstGeom prst="triangle">
+            <a:avLst/>
+          </a:prstGeom>
+          <a:noFill/>
+          <a:ln w="28575">
+            <a:solidFill>
+              <a:srgbClr val="8B1A2B"/>
+            </a:solidFill>
+          </a:ln>
+        </p:spPr>
+        <p:txBody>
+          <a:bodyPr/>
+          <a:lstStyle/>
+          <a:p>
+            <a:endParaRPr lang="fr-FR"/>
+          </a:p>
+        </p:txBody>
+      </p:sp>
+      <p:sp>
+        <p:nvSpPr>
+          <p:cNvPr id="62" name="Sil62"/>
+          <p:cNvSpPr/>
+          <p:nvPr/>
+        </p:nvSpPr>
+        <p:spPr>
+          <a:xfrm>
+            <a:off x="3271369" y="4619154"/>
+            <a:ext cx="1019952" cy="1019952"/>
+          </a:xfrm>
+          <a:prstGeom prst="ellipse">
+            <a:avLst/>
+          </a:prstGeom>
+          <a:noFill/>
+          <a:ln w="28575">
+            <a:solidFill>
+              <a:srgbClr val="8B1A2B"/>
+            </a:solidFill>
+          </a:ln>
+        </p:spPr>
+        <p:txBody>
+          <a:bodyPr/>
+          <a:lstStyle/>
+          <a:p>
+            <a:endParaRPr lang="fr-FR"/>
+          </a:p>
+        </p:txBody>
+      </p:sp>
+      <p:sp>
+        <p:nvSpPr>
+          <p:cNvPr id="63" name="Sil63"/>
+          <p:cNvSpPr/>
+          <p:nvPr/>
+        </p:nvSpPr>
+        <p:spPr>
+          <a:xfrm>
+            <a:off x="3356365" y="5029968"/>
+            <a:ext cx="849960" cy="184158"/>
+          </a:xfrm>
+          <a:prstGeom prst="roundRect">
+            <a:avLst>
+              <a:gd name="adj" fmla="val 25000"/>
+            </a:avLst>
+          </a:prstGeom>
+          <a:noFill/>
+          <a:ln w="28575">
+            <a:solidFill>
+              <a:srgbClr val="8B1A2B"/>
+            </a:solidFill>
+          </a:ln>
+        </p:spPr>
+        <p:txBody>
+          <a:bodyPr/>
+          <a:lstStyle/>
+          <a:p>
+            <a:endParaRPr lang="fr-FR"/>
+          </a:p>
+        </p:txBody>
+      </p:sp>
+      <p:sp>
+        <p:nvSpPr>
+          <p:cNvPr id="64" name="Sil64"/>
+          <p:cNvSpPr/>
+          <p:nvPr/>
+        </p:nvSpPr>
+        <p:spPr>
+          <a:xfrm>
+            <a:off x="3328033" y="5653272"/>
+            <a:ext cx="906624" cy="1204110"/>
+          </a:xfrm>
+          <a:prstGeom prst="roundRect">
+            <a:avLst>
+              <a:gd name="adj" fmla="val 25000"/>
+            </a:avLst>
+          </a:prstGeom>
+          <a:noFill/>
+          <a:ln w="28575">
+            <a:solidFill>
+              <a:srgbClr val="8B1A2B"/>
+            </a:solidFill>
+          </a:ln>
+        </p:spPr>
+        <p:txBody>
+          <a:bodyPr/>
+          <a:lstStyle/>
+          <a:p>
+            <a:endParaRPr lang="fr-FR"/>
+          </a:p>
+        </p:txBody>
+      </p:sp>
+      <p:sp>
+        <p:nvSpPr>
+          <p:cNvPr id="65" name="Sil65"/>
+          <p:cNvSpPr/>
+          <p:nvPr/>
+        </p:nvSpPr>
+        <p:spPr>
+          <a:xfrm>
+            <a:off x="3583021" y="5922426"/>
+            <a:ext cx="396648" cy="396648"/>
+          </a:xfrm>
+          <a:prstGeom prst="star5">
+            <a:avLst/>
+          </a:prstGeom>
+          <a:noFill/>
+          <a:ln w="28575">
+            <a:solidFill>
+              <a:srgbClr val="8B1A2B"/>
+            </a:solidFill>
+          </a:ln>
+        </p:spPr>
+        <p:txBody>
+          <a:bodyPr/>
+          <a:lstStyle/>
+          <a:p>
+            <a:endParaRPr lang="fr-FR"/>
+          </a:p>
+        </p:txBody>
+      </p:sp>
+      <p:sp>
+        <p:nvSpPr>
+          <p:cNvPr id="66" name="Sil66"/>
+          <p:cNvSpPr/>
+          <p:nvPr/>
+        </p:nvSpPr>
+        <p:spPr>
+          <a:xfrm>
+            <a:off x="3682183" y="6588228"/>
+            <a:ext cx="198324" cy="198324"/>
+          </a:xfrm>
+          <a:prstGeom prst="ellipse">
+            <a:avLst/>
+          </a:prstGeom>
+          <a:noFill/>
+          <a:ln w="28575">
+            <a:solidFill>
+              <a:srgbClr val="8B1A2B"/>
+            </a:solidFill>
+          </a:ln>
+        </p:spPr>
+        <p:txBody>
+          <a:bodyPr/>
+          <a:lstStyle/>
+          <a:p>
+            <a:endParaRPr lang="fr-FR"/>
+          </a:p>
+        </p:txBody>
+      </p:sp>
+      <p:sp>
+        <p:nvSpPr>
+          <p:cNvPr id="67" name="Sil67"/>
+          <p:cNvSpPr/>
+          <p:nvPr/>
+        </p:nvSpPr>
+        <p:spPr>
+          <a:xfrm>
+            <a:off x="2903053" y="5766600"/>
+            <a:ext cx="283320" cy="849960"/>
+          </a:xfrm>
+          <a:prstGeom prst="roundRect">
+            <a:avLst>
+              <a:gd name="adj" fmla="val 25000"/>
+            </a:avLst>
+          </a:prstGeom>
+          <a:noFill/>
+          <a:ln w="28575">
+            <a:solidFill>
+              <a:srgbClr val="8B1A2B"/>
+            </a:solidFill>
+          </a:ln>
+        </p:spPr>
+        <p:txBody>
+          <a:bodyPr/>
+          <a:lstStyle/>
+          <a:p>
+            <a:endParaRPr lang="fr-FR"/>
+          </a:p>
+        </p:txBody>
+      </p:sp>
+      <p:sp>
+        <p:nvSpPr>
+          <p:cNvPr id="68" name="Sil68"/>
+          <p:cNvSpPr/>
+          <p:nvPr/>
+        </p:nvSpPr>
+        <p:spPr>
+          <a:xfrm>
+            <a:off x="4376317" y="5766600"/>
+            <a:ext cx="283320" cy="849960"/>
+          </a:xfrm>
+          <a:prstGeom prst="roundRect">
+            <a:avLst>
+              <a:gd name="adj" fmla="val 25000"/>
+            </a:avLst>
+          </a:prstGeom>
+          <a:noFill/>
+          <a:ln w="28575">
+            <a:solidFill>
+              <a:srgbClr val="8B1A2B"/>
+            </a:solidFill>
+          </a:ln>
+        </p:spPr>
+        <p:txBody>
+          <a:bodyPr/>
+          <a:lstStyle/>
+          <a:p>
+            <a:endParaRPr lang="fr-FR"/>
+          </a:p>
+        </p:txBody>
+      </p:sp>
+      <p:sp>
+        <p:nvSpPr>
+          <p:cNvPr id="69" name="Sil69"/>
+          <p:cNvSpPr/>
+          <p:nvPr/>
+        </p:nvSpPr>
+        <p:spPr>
+          <a:xfrm>
+            <a:off x="2888887" y="6503232"/>
+            <a:ext cx="311652" cy="311652"/>
+          </a:xfrm>
+          <a:prstGeom prst="ellipse">
+            <a:avLst/>
+          </a:prstGeom>
+          <a:noFill/>
+          <a:ln w="28575">
+            <a:solidFill>
+              <a:srgbClr val="8B1A2B"/>
+            </a:solidFill>
+          </a:ln>
+        </p:spPr>
+        <p:txBody>
+          <a:bodyPr/>
+          <a:lstStyle/>
+          <a:p>
+            <a:endParaRPr lang="fr-FR"/>
+          </a:p>
+        </p:txBody>
+      </p:sp>
+      <p:sp>
+        <p:nvSpPr>
+          <p:cNvPr id="70" name="Sil70"/>
+          <p:cNvSpPr/>
+          <p:nvPr/>
+        </p:nvSpPr>
+        <p:spPr>
+          <a:xfrm>
+            <a:off x="4362151" y="6503232"/>
+            <a:ext cx="311652" cy="311652"/>
+          </a:xfrm>
+          <a:prstGeom prst="ellipse">
+            <a:avLst/>
+          </a:prstGeom>
+          <a:noFill/>
+          <a:ln w="28575">
+            <a:solidFill>
+              <a:srgbClr val="8B1A2B"/>
+            </a:solidFill>
+          </a:ln>
+        </p:spPr>
+        <p:txBody>
+          <a:bodyPr/>
+          <a:lstStyle/>
+          <a:p>
+            <a:endParaRPr lang="fr-FR"/>
+          </a:p>
+        </p:txBody>
+      </p:sp>
+      <p:sp>
+        <p:nvSpPr>
+          <p:cNvPr id="71" name="Sil71"/>
+          <p:cNvSpPr/>
+          <p:nvPr/>
+        </p:nvSpPr>
+        <p:spPr>
+          <a:xfrm>
+            <a:off x="3427195" y="6857382"/>
+            <a:ext cx="311652" cy="991620"/>
+          </a:xfrm>
+          <a:prstGeom prst="roundRect">
+            <a:avLst>
+              <a:gd name="adj" fmla="val 25000"/>
+            </a:avLst>
+          </a:prstGeom>
+          <a:noFill/>
+          <a:ln w="28575">
+            <a:solidFill>
+              <a:srgbClr val="8B1A2B"/>
+            </a:solidFill>
+          </a:ln>
+        </p:spPr>
+        <p:txBody>
+          <a:bodyPr/>
+          <a:lstStyle/>
+          <a:p>
+            <a:endParaRPr lang="fr-FR"/>
+          </a:p>
+        </p:txBody>
+      </p:sp>
+      <p:sp>
+        <p:nvSpPr>
+          <p:cNvPr id="72" name="Sil72"/>
+          <p:cNvSpPr/>
+          <p:nvPr/>
+        </p:nvSpPr>
+        <p:spPr>
+          <a:xfrm>
+            <a:off x="3823843" y="6857382"/>
+            <a:ext cx="311652" cy="991620"/>
+          </a:xfrm>
+          <a:prstGeom prst="roundRect">
+            <a:avLst>
+              <a:gd name="adj" fmla="val 25000"/>
+            </a:avLst>
+          </a:prstGeom>
+          <a:noFill/>
+          <a:ln w="28575">
+            <a:solidFill>
+              <a:srgbClr val="8B1A2B"/>
+            </a:solidFill>
+          </a:ln>
+        </p:spPr>
+        <p:txBody>
+          <a:bodyPr/>
+          <a:lstStyle/>
+          <a:p>
+            <a:endParaRPr lang="fr-FR"/>
+          </a:p>
+        </p:txBody>
+      </p:sp>
+      <p:sp>
+        <p:nvSpPr>
+          <p:cNvPr id="73" name="Sil73"/>
+          <p:cNvSpPr/>
+          <p:nvPr/>
+        </p:nvSpPr>
+        <p:spPr>
+          <a:xfrm>
+            <a:off x="3356365" y="7820670"/>
+            <a:ext cx="453312" cy="254988"/>
+          </a:xfrm>
+          <a:prstGeom prst="roundRect">
+            <a:avLst>
+              <a:gd name="adj" fmla="val 25000"/>
+            </a:avLst>
+          </a:prstGeom>
+          <a:noFill/>
+          <a:ln w="28575">
+            <a:solidFill>
+              <a:srgbClr val="8B1A2B"/>
+            </a:solidFill>
+          </a:ln>
+        </p:spPr>
+        <p:txBody>
+          <a:bodyPr/>
+          <a:lstStyle/>
+          <a:p>
+            <a:endParaRPr lang="fr-FR"/>
+          </a:p>
+        </p:txBody>
+      </p:sp>
+      <p:sp>
+        <p:nvSpPr>
+          <p:cNvPr id="74" name="Sil74"/>
+          <p:cNvSpPr/>
+          <p:nvPr/>
+        </p:nvSpPr>
+        <p:spPr>
+          <a:xfrm>
+            <a:off x="3753013" y="7820670"/>
+            <a:ext cx="453312" cy="254988"/>
+          </a:xfrm>
+          <a:prstGeom prst="roundRect">
+            <a:avLst>
+              <a:gd name="adj" fmla="val 25000"/>
+            </a:avLst>
+          </a:prstGeom>
+          <a:noFill/>
+          <a:ln w="28575">
+            <a:solidFill>
+              <a:srgbClr val="8B1A2B"/>
+            </a:solidFill>
+          </a:ln>
+        </p:spPr>
+        <p:txBody>
+          <a:bodyPr/>
+          <a:lstStyle/>
+          <a:p>
+            <a:endParaRPr lang="fr-FR"/>
+          </a:p>
+        </p:txBody>
+      </p:sp>
+      <p:sp>
+        <p:nvSpPr>
+          <p:cNvPr id="80" name="Text 80"/>
+          <p:cNvSpPr/>
+          <p:nvPr/>
+        </p:nvSpPr>
+        <p:spPr>
+          <a:xfrm>
+            <a:off x="1781425" y="9600000"/>
+            <a:ext cx="4000000" cy="400000"/>
+          </a:xfrm>
+          <a:prstGeom prst="rect">
+            <a:avLst/>
+          </a:prstGeom>
+          <a:noFill/>
+          <a:ln/>
+        </p:spPr>
+        <p:txBody>
+          <a:bodyPr wrap="square" lIns="0" tIns="0" rIns="0" bIns="0" rtlCol="0" anchor="t"/>
+          <a:lstStyle/>
+          <a:p>
+            <a:pPr marL="0" indent="0" algn="ctr">
+              <a:buNone/>
+            </a:pPr>
+            <a:r>
+              <a:rPr lang="fr-FR" sz="1400" b="0" i="1" dirty="0">
+                <a:solidFill>
+                  <a:srgbClr val="999999"/>
+                </a:solidFill>
+                <a:latin typeface="Poppins"/>
+              </a:rPr>
+              <a:t>Dessine-toi ici !</a:t>
+            </a:r>
+          </a:p>
+        </p:txBody>
+      </p:sp>
+    </p:spTree>
+  </p:cSld>
+  <p:clrMapOvr>
+    <a:masterClrMapping/>
+  </p:clrMapOvr>
+</p:sld>
+</file>
+
 <file path=ppt/slides/slide2.xml><?xml version="1.0" encoding="utf-8"?>
 <p:sld xmlns:a="http://schemas.openxmlformats.org/drawingml/2006/main" xmlns:r="http://schemas.openxmlformats.org/officeDocument/2006/relationships" xmlns:p="http://schemas.openxmlformats.org/presentationml/2006/main">
   <p:cSld>
@@ -6314,22 +8809,161 @@
           </a:prstGeom>
         </p:spPr>
       </p:pic>
-      <p:sp>
-        <p:nvSpPr>
-          <p:cNvPr id="6" name="Rectangle 5">
+    </p:spTree>
+  </p:cSld>
+  <p:clrMapOvr>
+    <a:masterClrMapping/>
+  </p:clrMapOvr>
+</p:sld>
+</file>
+
+<file path=ppt/slides/slide9.xml><?xml version="1.0" encoding="utf-8"?>
+<p:sld xmlns:a="http://schemas.openxmlformats.org/drawingml/2006/main" xmlns:r="http://schemas.openxmlformats.org/officeDocument/2006/relationships" xmlns:p="http://schemas.openxmlformats.org/presentationml/2006/main">
+  <p:cSld name="Slide 7">
+    <p:bg>
+      <p:bgPr>
+        <a:blipFill dpi="0" rotWithShape="1">
+          <a:blip r:embed="rId3">
+            <a:lum/>
+          </a:blip>
+          <a:srcRect/>
+          <a:stretch>
+            <a:fillRect/>
+          </a:stretch>
+        </a:blipFill>
+        <a:effectLst/>
+      </p:bgPr>
+    </p:bg>
+    <p:spTree>
+      <p:nvGrpSpPr>
+        <p:cNvPr id="1" name=""/>
+        <p:cNvGrpSpPr/>
+        <p:nvPr/>
+      </p:nvGrpSpPr>
+      <p:grpSpPr>
+        <a:xfrm>
+          <a:off x="0" y="0"/>
+          <a:ext cx="0" cy="0"/>
+          <a:chOff x="0" y="0"/>
+          <a:chExt cx="0" cy="0"/>
+        </a:xfrm>
+      </p:grpSpPr>
+      <p:sp>
+        <p:nvSpPr>
+          <p:cNvPr id="2" name="Text 0"/>
+          <p:cNvSpPr/>
+          <p:nvPr/>
+        </p:nvSpPr>
+        <p:spPr>
+          <a:xfrm>
+            <a:off x="457200" y="360000"/>
+            <a:ext cx="6647688" cy="648000"/>
+          </a:xfrm>
+          <a:prstGeom prst="rect">
+            <a:avLst/>
+          </a:prstGeom>
+          <a:noFill/>
+          <a:ln/>
+        </p:spPr>
+        <p:txBody>
+          <a:bodyPr wrap="square" lIns="0" tIns="0" rIns="0" bIns="0" rtlCol="0" anchor="ctr"/>
+          <a:lstStyle/>
+          <a:p>
+            <a:pPr marL="0" indent="0" algn="ctr">
+              <a:buNone/>
+            </a:pPr>
+            <a:r>
+              <a:rPr lang="en-US" sz="3000" b="1">
+                <a:solidFill>
+                  <a:srgbClr val="8B1A2B"/>
+                </a:solidFill>
+                <a:latin typeface="Poppins" pitchFamily="34" charset="0"/>
+                <a:ea typeface="Calibri" pitchFamily="34" charset="-122"/>
+                <a:cs typeface="Calibri" pitchFamily="34" charset="-120"/>
+              </a:rPr>
+              <a:t>Pour tes parents</a:t>
+            </a:r>
+            <a:endParaRPr lang="en-US" sz="3000"/>
+          </a:p>
+        </p:txBody>
+      </p:sp>
+      <p:sp>
+        <p:nvSpPr>
+          <p:cNvPr id="99" name="Footer"/>
+          <p:cNvSpPr/>
+          <p:nvPr/>
+        </p:nvSpPr>
+        <p:spPr>
+          <a:xfrm>
+            <a:off x="500000" y="10300000"/>
+            <a:ext cx="6562850" cy="300000"/>
+          </a:xfrm>
+          <a:prstGeom prst="rect">
+            <a:avLst/>
+          </a:prstGeom>
+          <a:noFill/>
+          <a:ln/>
+        </p:spPr>
+        <p:txBody>
+          <a:bodyPr wrap="square" lIns="0" tIns="0" rIns="0" bIns="0" rtlCol="0" anchor="ctr"/>
+          <a:lstStyle/>
+          <a:p>
+            <a:pPr marL="0" indent="0" algn="ctr">
+              <a:buNone/>
+            </a:pPr>
+            <a:r>
+              <a:rPr lang="fr-FR" sz="1000" i="1">
+                <a:solidFill>
+                  <a:srgbClr val="666666"/>
+                </a:solidFill>
+                <a:latin typeface="Poppins" pitchFamily="34" charset="0"/>
+                <a:ea typeface="Calibri" pitchFamily="34" charset="0"/>
+                <a:cs typeface="Calibri" pitchFamily="34" charset="0"/>
+              </a:rPr>
+              <a:t>Fait par l’association Sed’Occ France 04/2026</a:t>
+            </a:r>
+          </a:p>
+        </p:txBody>
+      </p:sp>
+      <p:pic>
+        <p:nvPicPr>
+          <p:cNvPr id="8" name="Image 7">
             <a:extLst>
               <a:ext uri="{FF2B5EF4-FFF2-40B4-BE49-F238E27FC236}">
-                <a16:creationId xmlns:a16="http://schemas.microsoft.com/office/drawing/2014/main" id="{E0B361EC-0B31-4A4E-94B4-F8CEAB4FC256}"/>
+                <a16:creationId xmlns:a16="http://schemas.microsoft.com/office/drawing/2014/main" id="{21E0B056-8D9F-8042-A02E-B988B66CF19F}"/>
               </a:ext>
             </a:extLst>
           </p:cNvPr>
-          <p:cNvSpPr/>
-          <p:nvPr/>
-        </p:nvSpPr>
-        <p:spPr>
-          <a:xfrm>
-            <a:off x="2033733" y="8353920"/>
-            <a:ext cx="3781425" cy="1628651"/>
+          <p:cNvPicPr>
+            <a:picLocks noChangeAspect="1"/>
+          </p:cNvPicPr>
+          <p:nvPr/>
+        </p:nvPicPr>
+        <p:blipFill rotWithShape="1">
+          <a:blip r:embed="rId6"/>
+          <a:srcRect l="9802" t="10888" r="15836" b="19876"/>
+          <a:stretch/>
+        </p:blipFill>
+        <p:spPr>
+          <a:xfrm>
+            <a:off x="6300000" y="9540000"/>
+            <a:ext cx="1080000" cy="1007999"/>
+          </a:xfrm>
+          <a:prstGeom prst="rect">
+            <a:avLst/>
+          </a:prstGeom>
+        </p:spPr>
+      </p:pic>
+      <p:sp>
+        <p:nvSpPr>
+          <p:cNvPr id="6" name="Rectangle 5"/>
+          <p:cNvSpPr/>
+          <p:nvPr/>
+        </p:nvSpPr>
+        <p:spPr>
+          <a:xfrm>
+            <a:off x="1281425" y="4200000"/>
+            <a:ext cx="5000000" cy="2400000"/>
           </a:xfrm>
           <a:prstGeom prst="rect">
             <a:avLst/>
@@ -6340,38 +8974,6 @@
             <a:spAutoFit/>
           </a:bodyPr>
           <a:lstStyle/>
-          <a:p>
-            <a:pPr algn="ctr">
-              <a:spcBef>
-                <a:spcPts val="800"/>
-              </a:spcBef>
-            </a:pPr>
-            <a:r>
-              <a:rPr lang="fr-FR" sz="1000" dirty="0">
-                <a:solidFill>
-                  <a:srgbClr val="CCBBBB"/>
-                </a:solidFill>
-                <a:latin typeface="Poppins"/>
-              </a:rPr>
-              <a:t>━━━━━━━━━━━━━━━━━━━━━━━━</a:t>
-            </a:r>
-          </a:p>
-          <a:p>
-            <a:pPr algn="ctr">
-              <a:spcBef>
-                <a:spcPts val="400"/>
-              </a:spcBef>
-            </a:pPr>
-            <a:r>
-              <a:rPr lang="fr-FR" sz="2400" b="1" dirty="0">
-                <a:solidFill>
-                  <a:srgbClr val="8B1A2B"/>
-                </a:solidFill>
-                <a:latin typeface="Poppins"/>
-              </a:rPr>
-              <a:t>Pour tes parents</a:t>
-            </a:r>
-          </a:p>
           <a:p>
             <a:pPr algn="ctr">
               <a:spcBef>
@@ -6379,7 +8981,7 @@
               </a:spcBef>
             </a:pPr>
             <a:r>
-              <a:rPr lang="fr-FR" sz="2000" dirty="0">
+              <a:rPr lang="fr-FR" sz="2400" dirty="0">
                 <a:solidFill>
                   <a:srgbClr val="666666"/>
                 </a:solidFill>
@@ -6388,7 +8990,7 @@
               <a:t>Site internet : </a:t>
             </a:r>
             <a:r>
-              <a:rPr lang="fr-FR" sz="2000" dirty="0" err="1">
+              <a:rPr lang="fr-FR" sz="2400" dirty="0" err="1">
                 <a:solidFill>
                   <a:srgbClr val="666666"/>
                 </a:solidFill>
@@ -6396,7 +8998,7 @@
               </a:rPr>
               <a:t>www.sedocc.fr</a:t>
             </a:r>
-            <a:endParaRPr lang="fr-FR" sz="2000" dirty="0">
+            <a:endParaRPr lang="fr-FR" sz="2400" dirty="0">
               <a:solidFill>
                 <a:srgbClr val="666666"/>
               </a:solidFill>
@@ -6406,7 +9008,7 @@
           <a:p>
             <a:pPr algn="ctr"/>
             <a:r>
-              <a:rPr lang="fr-FR" sz="2000" dirty="0">
+              <a:rPr lang="fr-FR" sz="2400" dirty="0">
                 <a:solidFill>
                   <a:srgbClr val="666666"/>
                 </a:solidFill>
@@ -6418,7 +9020,7 @@
           <a:p>
             <a:pPr algn="ctr"/>
             <a:r>
-              <a:rPr lang="fr-FR" sz="2000" dirty="0">
+              <a:rPr lang="fr-FR" sz="2400" dirty="0">
                 <a:solidFill>
                   <a:srgbClr val="666666"/>
                 </a:solidFill>
@@ -6427,7 +9029,7 @@
               <a:t>Facebook : </a:t>
             </a:r>
             <a:r>
-              <a:rPr lang="fr-FR" sz="2000" dirty="0" err="1">
+              <a:rPr lang="fr-FR" sz="2400" dirty="0" err="1">
                 <a:solidFill>
                   <a:srgbClr val="666666"/>
                 </a:solidFill>

</xml_diff>

<commit_message>
Livret enfant : mettre en ligne le PowerPoint retouche et corriger l'affichage mobile
L'Armure Secrete passe sur sa propre ligne pour eviter que "(les vetements
de compression)" soit coupe au milieu sur mobile. PDF et PowerPoint mis a
jour avec vos dernieres retouches.

Co-Authored-By: Claude Sonnet 5 <noreply@anthropic.com>
</commit_message>
<xml_diff>
--- a/documents/Livret-SED-enfant-SedOcc.pptx
+++ b/documents/Livret-SED-enfant-SedOcc.pptx
@@ -6810,7 +6810,7 @@
         </p:blipFill>
         <p:spPr>
           <a:xfrm>
-            <a:off x="408928" y="3221469"/>
+            <a:off x="408928" y="3384109"/>
             <a:ext cx="1456640" cy="1196253"/>
           </a:xfrm>
           <a:prstGeom prst="ellipse">
@@ -6840,7 +6840,7 @@
         </p:nvSpPr>
         <p:spPr>
           <a:xfrm>
-            <a:off x="1437639" y="2622902"/>
+            <a:off x="1983275" y="2904085"/>
             <a:ext cx="5317688" cy="1750000"/>
           </a:xfrm>
           <a:prstGeom prst="rect">
@@ -6865,8 +6865,13 @@
               </a:rPr>
               <a:t>Les Boucliers Magiques </a:t>
             </a:r>
-            <a:r>
-              <a:rPr lang="fr-FR" sz="2400" b="0" dirty="0">
+          </a:p>
+          <a:p>
+            <a:pPr marL="0" indent="0" algn="l">
+              <a:buNone/>
+            </a:pPr>
+            <a:r>
+              <a:rPr lang="fr-FR" sz="2000" b="0" dirty="0">
                 <a:solidFill>
                   <a:srgbClr val="8B1A2B"/>
                 </a:solidFill>
@@ -6874,6 +6879,12 @@
               </a:rPr>
               <a:t>(les attelles)</a:t>
             </a:r>
+            <a:endParaRPr lang="fr-FR" sz="2400" b="0" dirty="0">
+              <a:solidFill>
+                <a:srgbClr val="8B1A2B"/>
+              </a:solidFill>
+              <a:latin typeface="Poppins"/>
+            </a:endParaRPr>
           </a:p>
         </p:txBody>
       </p:sp>
@@ -6885,7 +6896,7 @@
         </p:nvSpPr>
         <p:spPr>
           <a:xfrm>
-            <a:off x="1983275" y="3235469"/>
+            <a:off x="1983275" y="3651115"/>
             <a:ext cx="4889759" cy="610719"/>
           </a:xfrm>
           <a:prstGeom prst="rect">
@@ -6929,7 +6940,7 @@
         </p:blipFill>
         <p:spPr>
           <a:xfrm>
-            <a:off x="457200" y="5586739"/>
+            <a:off x="433082" y="5619383"/>
             <a:ext cx="1432486" cy="1186358"/>
           </a:xfrm>
           <a:prstGeom prst="ellipse">
@@ -6959,8 +6970,8 @@
         </p:nvSpPr>
         <p:spPr>
           <a:xfrm>
-            <a:off x="1555345" y="4771859"/>
-            <a:ext cx="5507503" cy="1750000"/>
+            <a:off x="2079500" y="5170641"/>
+            <a:ext cx="5549543" cy="1750000"/>
           </a:xfrm>
           <a:prstGeom prst="rect">
             <a:avLst/>
@@ -6982,10 +6993,15 @@
                 </a:solidFill>
                 <a:latin typeface="Poppins"/>
               </a:rPr>
-              <a:t>L'Armure Secrète </a:t>
-            </a:r>
-            <a:r>
-              <a:rPr lang="fr-FR" sz="2400" b="0" dirty="0">
+              <a:t>L'Armure Secrète</a:t>
+            </a:r>
+          </a:p>
+          <a:p>
+            <a:pPr marL="0" indent="0" algn="l">
+              <a:buNone/>
+            </a:pPr>
+            <a:r>
+              <a:rPr lang="fr-FR" sz="2000" b="0" dirty="0">
                 <a:solidFill>
                   <a:srgbClr val="8B1A2B"/>
                 </a:solidFill>
@@ -6993,6 +7009,12 @@
               </a:rPr>
               <a:t>(les vêtements de compression)</a:t>
             </a:r>
+            <a:endParaRPr lang="fr-FR" sz="2400" b="0" dirty="0">
+              <a:solidFill>
+                <a:srgbClr val="8B1A2B"/>
+              </a:solidFill>
+              <a:latin typeface="Poppins"/>
+            </a:endParaRPr>
           </a:p>
         </p:txBody>
       </p:sp>
@@ -7004,7 +7026,7 @@
         </p:nvSpPr>
         <p:spPr>
           <a:xfrm>
-            <a:off x="2079500" y="5675996"/>
+            <a:off x="2079500" y="5949602"/>
             <a:ext cx="4793534" cy="1200000"/>
           </a:xfrm>
           <a:prstGeom prst="rect">
@@ -7048,8 +7070,8 @@
         </p:blipFill>
         <p:spPr>
           <a:xfrm>
-            <a:off x="520569" y="8168217"/>
-            <a:ext cx="1462706" cy="1175742"/>
+            <a:off x="459698" y="8083651"/>
+            <a:ext cx="1405870" cy="1175742"/>
           </a:xfrm>
           <a:prstGeom prst="ellipse">
             <a:avLst/>
@@ -7078,8 +7100,8 @@
         </p:nvSpPr>
         <p:spPr>
           <a:xfrm>
-            <a:off x="1702300" y="7318044"/>
-            <a:ext cx="5317688" cy="1750000"/>
+            <a:off x="2079500" y="7620840"/>
+            <a:ext cx="5402588" cy="1750000"/>
           </a:xfrm>
           <a:prstGeom prst="rect">
             <a:avLst/>
@@ -7101,10 +7123,15 @@
                 </a:solidFill>
                 <a:latin typeface="Poppins"/>
               </a:rPr>
-              <a:t>Les Super-Propulseurs </a:t>
-            </a:r>
-            <a:r>
-              <a:rPr lang="fr-FR" sz="2400" b="0" dirty="0">
+              <a:t>Les Super-Propulseurs</a:t>
+            </a:r>
+          </a:p>
+          <a:p>
+            <a:pPr marL="0" indent="0" algn="l">
+              <a:buNone/>
+            </a:pPr>
+            <a:r>
+              <a:rPr lang="fr-FR" sz="2000" b="0" dirty="0">
                 <a:solidFill>
                   <a:srgbClr val="8B1A2B"/>
                 </a:solidFill>
@@ -7112,6 +7139,12 @@
               </a:rPr>
               <a:t>(les béquilles ou le fauteuil)</a:t>
             </a:r>
+            <a:endParaRPr lang="fr-FR" sz="2400" b="0" dirty="0">
+              <a:solidFill>
+                <a:srgbClr val="8B1A2B"/>
+              </a:solidFill>
+              <a:latin typeface="Poppins"/>
+            </a:endParaRPr>
           </a:p>
         </p:txBody>
       </p:sp>
@@ -7123,7 +7156,7 @@
         </p:nvSpPr>
         <p:spPr>
           <a:xfrm>
-            <a:off x="2079500" y="8209482"/>
+            <a:off x="2079500" y="8355156"/>
             <a:ext cx="4793534" cy="1200000"/>
           </a:xfrm>
           <a:prstGeom prst="rect">

</xml_diff>